<commit_message>
capability Slides, template creation,
</commit_message>
<xml_diff>
--- a/skills_templates.pptx
+++ b/skills_templates.pptx
@@ -3659,17 +3659,18 @@
         <p:spPr>
           <a:xfrm>
             <a:off x="0" y="0"/>
-            <a:ext cx="12188952" cy="6858000"/>
+            <a:ext cx="5852160" cy="91440"/>
           </a:xfrm>
           <a:prstGeom prst="rect">
             <a:avLst/>
           </a:prstGeom>
           <a:solidFill>
-            <a:srgbClr val="F0F2F1"/>
+            <a:srgbClr val="C02026"/>
           </a:solidFill>
           <a:ln>
             <a:noFill/>
           </a:ln>
+          <a:effectLst/>
         </p:spPr>
         <p:style>
           <a:lnRef idx="1">
@@ -3701,18 +3702,19 @@
         </p:nvSpPr>
         <p:spPr>
           <a:xfrm>
-            <a:off x="0" y="0"/>
-            <a:ext cx="12188952" cy="960120"/>
+            <a:off x="5852160" y="0"/>
+            <a:ext cx="6336792" cy="91440"/>
           </a:xfrm>
           <a:prstGeom prst="rect">
             <a:avLst/>
           </a:prstGeom>
           <a:solidFill>
-            <a:srgbClr val="2C6E66"/>
+            <a:srgbClr val="3A8B82"/>
           </a:solidFill>
           <a:ln>
             <a:noFill/>
           </a:ln>
+          <a:effectLst/>
         </p:spPr>
         <p:style>
           <a:lnRef idx="1">
@@ -3738,92 +3740,25 @@
       </p:sp>
       <p:sp>
         <p:nvSpPr>
-          <p:cNvPr id="4" name="TextBox 3"/>
-          <p:cNvSpPr txBox="1"/>
-          <p:nvPr/>
-        </p:nvSpPr>
-        <p:spPr>
-          <a:xfrm>
-            <a:off x="274320" y="82296"/>
-            <a:ext cx="11823192" cy="512064"/>
-          </a:xfrm>
-          <a:prstGeom prst="rect">
-            <a:avLst/>
-          </a:prstGeom>
-          <a:noFill/>
-        </p:spPr>
-        <p:txBody>
-          <a:bodyPr wrap="square" anchor="t">
-            <a:spAutoFit/>
-          </a:bodyPr>
-          <a:lstStyle/>
-          <a:p>
-            <a:pPr algn="l"/>
-            <a:r>
-              <a:rPr sz="1700" b="1" i="0">
-                <a:solidFill>
-                  <a:srgbClr val="FFFFFF"/>
-                </a:solidFill>
-              </a:rPr>
-              <a:t>WHERE J2W HAS DELIVERED  —  {{SKILLS_HEADER}}</a:t>
-            </a:r>
-          </a:p>
-        </p:txBody>
-      </p:sp>
-      <p:sp>
-        <p:nvSpPr>
-          <p:cNvPr id="5" name="TextBox 4"/>
-          <p:cNvSpPr txBox="1"/>
-          <p:nvPr/>
-        </p:nvSpPr>
-        <p:spPr>
-          <a:xfrm>
-            <a:off x="274320" y="612648"/>
-            <a:ext cx="11823192" cy="292608"/>
-          </a:xfrm>
-          <a:prstGeom prst="rect">
-            <a:avLst/>
-          </a:prstGeom>
-          <a:noFill/>
-        </p:spPr>
-        <p:txBody>
-          <a:bodyPr wrap="square" anchor="t">
-            <a:spAutoFit/>
-          </a:bodyPr>
-          <a:lstStyle/>
-          <a:p>
-            <a:pPr algn="l"/>
-            <a:r>
-              <a:rPr sz="900" b="0" i="1">
-                <a:solidFill>
-                  <a:srgbClr val="CFE7E2"/>
-                </a:solidFill>
-              </a:rPr>
-              <a:t>Skills deployed across J2W client engagements</a:t>
-            </a:r>
-          </a:p>
-        </p:txBody>
-      </p:sp>
-      <p:sp>
-        <p:nvSpPr>
-          <p:cNvPr id="6" name="Rectangle 5"/>
+          <p:cNvPr id="4" name="Rectangle 3"/>
           <p:cNvSpPr/>
           <p:nvPr/>
         </p:nvSpPr>
         <p:spPr>
           <a:xfrm>
-            <a:off x="182880" y="1051560"/>
-            <a:ext cx="5074920" cy="5715000"/>
+            <a:off x="228600" y="274320"/>
+            <a:ext cx="59436" cy="475488"/>
           </a:xfrm>
           <a:prstGeom prst="rect">
             <a:avLst/>
           </a:prstGeom>
           <a:solidFill>
-            <a:srgbClr val="FFFFFF"/>
+            <a:srgbClr val="C02026"/>
           </a:solidFill>
           <a:ln>
             <a:noFill/>
           </a:ln>
+          <a:effectLst/>
         </p:spPr>
         <p:style>
           <a:lnRef idx="1">
@@ -3849,24 +3784,95 @@
       </p:sp>
       <p:sp>
         <p:nvSpPr>
+          <p:cNvPr id="5" name="TextBox 4"/>
+          <p:cNvSpPr txBox="1"/>
+          <p:nvPr/>
+        </p:nvSpPr>
+        <p:spPr>
+          <a:xfrm>
+            <a:off x="402336" y="237744"/>
+            <a:ext cx="11338560" cy="475488"/>
+          </a:xfrm>
+          <a:prstGeom prst="rect">
+            <a:avLst/>
+          </a:prstGeom>
+          <a:noFill/>
+        </p:spPr>
+        <p:txBody>
+          <a:bodyPr wrap="square" anchor="t" tIns="0" bIns="0">
+            <a:spAutoFit/>
+          </a:bodyPr>
+          <a:lstStyle/>
+          <a:p>
+            <a:pPr algn="l"/>
+            <a:r>
+              <a:rPr sz="2400" b="1" i="0">
+                <a:solidFill>
+                  <a:srgbClr val="111110"/>
+                </a:solidFill>
+                <a:latin typeface="Calibri"/>
+              </a:rPr>
+              <a:t>WHERE J2W HAS DELIVERED</a:t>
+            </a:r>
+          </a:p>
+        </p:txBody>
+      </p:sp>
+      <p:sp>
+        <p:nvSpPr>
+          <p:cNvPr id="6" name="TextBox 5"/>
+          <p:cNvSpPr txBox="1"/>
+          <p:nvPr/>
+        </p:nvSpPr>
+        <p:spPr>
+          <a:xfrm>
+            <a:off x="402336" y="731520"/>
+            <a:ext cx="11521440" cy="310896"/>
+          </a:xfrm>
+          <a:prstGeom prst="rect">
+            <a:avLst/>
+          </a:prstGeom>
+          <a:noFill/>
+        </p:spPr>
+        <p:txBody>
+          <a:bodyPr wrap="square" anchor="t" tIns="0" bIns="0">
+            <a:spAutoFit/>
+          </a:bodyPr>
+          <a:lstStyle/>
+          <a:p>
+            <a:pPr algn="l"/>
+            <a:r>
+              <a:rPr sz="1400" b="1" i="0">
+                <a:solidFill>
+                  <a:srgbClr val="3A8B82"/>
+                </a:solidFill>
+                <a:latin typeface="Calibri"/>
+              </a:rPr>
+              <a:t>SKILLS DEPLOYED:  {{SKILLS_HEADER}}</a:t>
+            </a:r>
+          </a:p>
+        </p:txBody>
+      </p:sp>
+      <p:sp>
+        <p:nvSpPr>
           <p:cNvPr id="7" name="Rectangle 6"/>
           <p:cNvSpPr/>
           <p:nvPr/>
         </p:nvSpPr>
         <p:spPr>
           <a:xfrm>
-            <a:off x="182880" y="1051560"/>
-            <a:ext cx="45720" cy="5715000"/>
+            <a:off x="0" y="6766560"/>
+            <a:ext cx="12188952" cy="91440"/>
           </a:xfrm>
           <a:prstGeom prst="rect">
             <a:avLst/>
           </a:prstGeom>
           <a:solidFill>
-            <a:srgbClr val="2C6E66"/>
+            <a:srgbClr val="3A8B82"/>
           </a:solidFill>
           <a:ln>
             <a:noFill/>
           </a:ln>
+          <a:effectLst/>
         </p:spPr>
         <p:style>
           <a:lnRef idx="1">
@@ -3892,58 +3898,27 @@
       </p:sp>
       <p:sp>
         <p:nvSpPr>
-          <p:cNvPr id="8" name="TextBox 7"/>
-          <p:cNvSpPr txBox="1"/>
-          <p:nvPr/>
-        </p:nvSpPr>
-        <p:spPr>
-          <a:xfrm>
-            <a:off x="320040" y="1188720"/>
-            <a:ext cx="4800600" cy="256032"/>
-          </a:xfrm>
-          <a:prstGeom prst="rect">
-            <a:avLst/>
-          </a:prstGeom>
-          <a:noFill/>
-        </p:spPr>
-        <p:txBody>
-          <a:bodyPr wrap="square" anchor="t">
-            <a:spAutoFit/>
-          </a:bodyPr>
-          <a:lstStyle/>
-          <a:p>
-            <a:pPr algn="l"/>
-            <a:r>
-              <a:rPr sz="1100" b="1" i="0">
-                <a:solidFill>
-                  <a:srgbClr val="2C6E66"/>
-                </a:solidFill>
-              </a:rPr>
-              <a:t>DEPLOYMENT SUMMARY</a:t>
-            </a:r>
-          </a:p>
-        </p:txBody>
-      </p:sp>
-      <p:sp>
-        <p:nvSpPr>
-          <p:cNvPr id="9" name="Rectangle 8"/>
+          <p:cNvPr id="8" name="Rectangle 7"/>
           <p:cNvSpPr/>
           <p:nvPr/>
         </p:nvSpPr>
         <p:spPr>
           <a:xfrm>
-            <a:off x="320040" y="1481328"/>
-            <a:ext cx="4800600" cy="20116"/>
+            <a:off x="274320" y="1207008"/>
+            <a:ext cx="5074920" cy="5394959"/>
           </a:xfrm>
           <a:prstGeom prst="rect">
             <a:avLst/>
           </a:prstGeom>
           <a:solidFill>
-            <a:srgbClr val="7FB2A9"/>
+            <a:srgbClr val="FFFFFF"/>
           </a:solidFill>
-          <a:ln>
-            <a:noFill/>
+          <a:ln w="9525">
+            <a:solidFill>
+              <a:srgbClr val="DEDEDE"/>
+            </a:solidFill>
           </a:ln>
+          <a:effectLst/>
         </p:spPr>
         <p:style>
           <a:lnRef idx="1">
@@ -3969,58 +3944,25 @@
       </p:sp>
       <p:sp>
         <p:nvSpPr>
-          <p:cNvPr id="10" name="TextBox 9"/>
-          <p:cNvSpPr txBox="1"/>
-          <p:nvPr/>
-        </p:nvSpPr>
-        <p:spPr>
-          <a:xfrm>
-            <a:off x="320040" y="1536192"/>
-            <a:ext cx="4846320" cy="5138927"/>
-          </a:xfrm>
-          <a:prstGeom prst="rect">
-            <a:avLst/>
-          </a:prstGeom>
-          <a:noFill/>
-        </p:spPr>
-        <p:txBody>
-          <a:bodyPr wrap="square" anchor="t">
-            <a:spAutoFit/>
-          </a:bodyPr>
-          <a:lstStyle/>
-          <a:p>
-            <a:pPr algn="l"/>
-            <a:r>
-              <a:rPr sz="1000" b="0" i="0">
-                <a:solidFill>
-                  <a:srgbClr val="111110"/>
-                </a:solidFill>
-              </a:rPr>
-              <a:t>{{SKILL_SUMMARY}}</a:t>
-            </a:r>
-          </a:p>
-        </p:txBody>
-      </p:sp>
-      <p:sp>
-        <p:nvSpPr>
-          <p:cNvPr id="11" name="Rectangle 10"/>
+          <p:cNvPr id="9" name="Rectangle 8"/>
           <p:cNvSpPr/>
           <p:nvPr/>
         </p:nvSpPr>
         <p:spPr>
           <a:xfrm>
-            <a:off x="5468112" y="1051560"/>
-            <a:ext cx="6537959" cy="5715000"/>
+            <a:off x="274320" y="1207008"/>
+            <a:ext cx="54864" cy="5394959"/>
           </a:xfrm>
           <a:prstGeom prst="rect">
             <a:avLst/>
           </a:prstGeom>
           <a:solidFill>
-            <a:srgbClr val="FFFFFF"/>
+            <a:srgbClr val="C02026"/>
           </a:solidFill>
           <a:ln>
             <a:noFill/>
           </a:ln>
+          <a:effectLst/>
         </p:spPr>
         <p:style>
           <a:lnRef idx="1">
@@ -4046,24 +3988,60 @@
       </p:sp>
       <p:sp>
         <p:nvSpPr>
-          <p:cNvPr id="12" name="Rectangle 11"/>
+          <p:cNvPr id="10" name="TextBox 9"/>
+          <p:cNvSpPr txBox="1"/>
+          <p:nvPr/>
+        </p:nvSpPr>
+        <p:spPr>
+          <a:xfrm>
+            <a:off x="420623" y="1353312"/>
+            <a:ext cx="4782312" cy="256032"/>
+          </a:xfrm>
+          <a:prstGeom prst="rect">
+            <a:avLst/>
+          </a:prstGeom>
+          <a:noFill/>
+        </p:spPr>
+        <p:txBody>
+          <a:bodyPr wrap="square" anchor="t" tIns="0" bIns="0">
+            <a:spAutoFit/>
+          </a:bodyPr>
+          <a:lstStyle/>
+          <a:p>
+            <a:pPr algn="l"/>
+            <a:r>
+              <a:rPr sz="1100" b="1" i="0">
+                <a:solidFill>
+                  <a:srgbClr val="3A8B82"/>
+                </a:solidFill>
+                <a:latin typeface="Calibri"/>
+              </a:rPr>
+              <a:t>DEPLOYMENT SUMMARY</a:t>
+            </a:r>
+          </a:p>
+        </p:txBody>
+      </p:sp>
+      <p:sp>
+        <p:nvSpPr>
+          <p:cNvPr id="11" name="Rectangle 10"/>
           <p:cNvSpPr/>
           <p:nvPr/>
         </p:nvSpPr>
         <p:spPr>
           <a:xfrm>
-            <a:off x="5468112" y="1051560"/>
-            <a:ext cx="6537959" cy="45720"/>
+            <a:off x="420623" y="1627632"/>
+            <a:ext cx="4782312" cy="20116"/>
           </a:xfrm>
           <a:prstGeom prst="rect">
             <a:avLst/>
           </a:prstGeom>
           <a:solidFill>
-            <a:srgbClr val="2C6E66"/>
+            <a:srgbClr val="3A8B82"/>
           </a:solidFill>
           <a:ln>
             <a:noFill/>
           </a:ln>
+          <a:effectLst/>
         </p:spPr>
         <p:style>
           <a:lnRef idx="1">
@@ -4089,14 +4067,14 @@
       </p:sp>
       <p:sp>
         <p:nvSpPr>
-          <p:cNvPr id="13" name="TextBox 12"/>
+          <p:cNvPr id="12" name="TextBox 11"/>
           <p:cNvSpPr txBox="1"/>
           <p:nvPr/>
         </p:nvSpPr>
         <p:spPr>
           <a:xfrm>
-            <a:off x="5605272" y="1188720"/>
-            <a:ext cx="6263640" cy="256032"/>
+            <a:off x="420623" y="1755648"/>
+            <a:ext cx="4782312" cy="4773167"/>
           </a:xfrm>
           <a:prstGeom prst="rect">
             <a:avLst/>
@@ -4104,43 +4082,47 @@
           <a:noFill/>
         </p:spPr>
         <p:txBody>
-          <a:bodyPr wrap="square" anchor="t">
+          <a:bodyPr wrap="square" anchor="t" tIns="0" bIns="0">
             <a:spAutoFit/>
           </a:bodyPr>
           <a:lstStyle/>
           <a:p>
             <a:pPr algn="l"/>
             <a:r>
-              <a:rPr sz="1100" b="1" i="0">
+              <a:rPr sz="1000" b="0" i="0">
                 <a:solidFill>
-                  <a:srgbClr val="2C6E66"/>
+                  <a:srgbClr val="3E3E3E"/>
                 </a:solidFill>
+                <a:latin typeface="Calibri"/>
               </a:rPr>
-              <a:t>SKILL DISTRIBUTION</a:t>
-            </a:r>
-          </a:p>
-        </p:txBody>
-      </p:sp>
-      <p:sp>
-        <p:nvSpPr>
-          <p:cNvPr id="14" name="Rectangle 13"/>
+              <a:t>{{SKILL_SUMMARY}}</a:t>
+            </a:r>
+          </a:p>
+        </p:txBody>
+      </p:sp>
+      <p:sp>
+        <p:nvSpPr>
+          <p:cNvPr id="13" name="Rectangle 12"/>
           <p:cNvSpPr/>
           <p:nvPr/>
         </p:nvSpPr>
         <p:spPr>
           <a:xfrm>
-            <a:off x="5605272" y="1481328"/>
-            <a:ext cx="6263640" cy="20116"/>
+            <a:off x="5568696" y="1207008"/>
+            <a:ext cx="6345936" cy="5394959"/>
           </a:xfrm>
           <a:prstGeom prst="rect">
             <a:avLst/>
           </a:prstGeom>
           <a:solidFill>
-            <a:srgbClr val="7FB2A9"/>
+            <a:srgbClr val="FFFFFF"/>
           </a:solidFill>
-          <a:ln>
-            <a:noFill/>
+          <a:ln w="9525">
+            <a:solidFill>
+              <a:srgbClr val="DEDEDE"/>
+            </a:solidFill>
           </a:ln>
+          <a:effectLst/>
         </p:spPr>
         <p:style>
           <a:lnRef idx="1">
@@ -4166,14 +4148,58 @@
       </p:sp>
       <p:sp>
         <p:nvSpPr>
+          <p:cNvPr id="14" name="Rectangle 13"/>
+          <p:cNvSpPr/>
+          <p:nvPr/>
+        </p:nvSpPr>
+        <p:spPr>
+          <a:xfrm>
+            <a:off x="5568696" y="1207008"/>
+            <a:ext cx="6345936" cy="54864"/>
+          </a:xfrm>
+          <a:prstGeom prst="rect">
+            <a:avLst/>
+          </a:prstGeom>
+          <a:solidFill>
+            <a:srgbClr val="3A8B82"/>
+          </a:solidFill>
+          <a:ln>
+            <a:noFill/>
+          </a:ln>
+          <a:effectLst/>
+        </p:spPr>
+        <p:style>
+          <a:lnRef idx="1">
+            <a:schemeClr val="accent1"/>
+          </a:lnRef>
+          <a:fillRef idx="3">
+            <a:schemeClr val="accent1"/>
+          </a:fillRef>
+          <a:effectRef idx="2">
+            <a:schemeClr val="accent1"/>
+          </a:effectRef>
+          <a:fontRef idx="minor">
+            <a:schemeClr val="lt1"/>
+          </a:fontRef>
+        </p:style>
+        <p:txBody>
+          <a:bodyPr rtlCol="0" anchor="ctr"/>
+          <a:lstStyle/>
+          <a:p>
+            <a:pPr algn="ctr"/>
+          </a:p>
+        </p:txBody>
+      </p:sp>
+      <p:sp>
+        <p:nvSpPr>
           <p:cNvPr id="15" name="TextBox 14"/>
           <p:cNvSpPr txBox="1"/>
           <p:nvPr/>
         </p:nvSpPr>
         <p:spPr>
           <a:xfrm>
-            <a:off x="5605272" y="1536192"/>
-            <a:ext cx="6263640" cy="5138927"/>
+            <a:off x="5715000" y="1353312"/>
+            <a:ext cx="6053328" cy="256032"/>
           </a:xfrm>
           <a:prstGeom prst="rect">
             <a:avLst/>
@@ -4181,17 +4207,97 @@
           <a:noFill/>
         </p:spPr>
         <p:txBody>
-          <a:bodyPr wrap="square" anchor="t">
+          <a:bodyPr wrap="square" anchor="t" tIns="0" bIns="0">
             <a:spAutoFit/>
           </a:bodyPr>
           <a:lstStyle/>
           <a:p>
             <a:pPr algn="l"/>
             <a:r>
+              <a:rPr sz="1100" b="1" i="0">
+                <a:solidFill>
+                  <a:srgbClr val="3A8B82"/>
+                </a:solidFill>
+                <a:latin typeface="Calibri"/>
+              </a:rPr>
+              <a:t>SKILL DISTRIBUTION</a:t>
+            </a:r>
+          </a:p>
+        </p:txBody>
+      </p:sp>
+      <p:sp>
+        <p:nvSpPr>
+          <p:cNvPr id="16" name="Rectangle 15"/>
+          <p:cNvSpPr/>
+          <p:nvPr/>
+        </p:nvSpPr>
+        <p:spPr>
+          <a:xfrm>
+            <a:off x="5715000" y="1627632"/>
+            <a:ext cx="6053328" cy="20116"/>
+          </a:xfrm>
+          <a:prstGeom prst="rect">
+            <a:avLst/>
+          </a:prstGeom>
+          <a:solidFill>
+            <a:srgbClr val="3A8B82"/>
+          </a:solidFill>
+          <a:ln>
+            <a:noFill/>
+          </a:ln>
+          <a:effectLst/>
+        </p:spPr>
+        <p:style>
+          <a:lnRef idx="1">
+            <a:schemeClr val="accent1"/>
+          </a:lnRef>
+          <a:fillRef idx="3">
+            <a:schemeClr val="accent1"/>
+          </a:fillRef>
+          <a:effectRef idx="2">
+            <a:schemeClr val="accent1"/>
+          </a:effectRef>
+          <a:fontRef idx="minor">
+            <a:schemeClr val="lt1"/>
+          </a:fontRef>
+        </p:style>
+        <p:txBody>
+          <a:bodyPr rtlCol="0" anchor="ctr"/>
+          <a:lstStyle/>
+          <a:p>
+            <a:pPr algn="ctr"/>
+          </a:p>
+        </p:txBody>
+      </p:sp>
+      <p:sp>
+        <p:nvSpPr>
+          <p:cNvPr id="17" name="TextBox 16"/>
+          <p:cNvSpPr txBox="1"/>
+          <p:nvPr/>
+        </p:nvSpPr>
+        <p:spPr>
+          <a:xfrm>
+            <a:off x="5715000" y="1755648"/>
+            <a:ext cx="6053328" cy="4773167"/>
+          </a:xfrm>
+          <a:prstGeom prst="rect">
+            <a:avLst/>
+          </a:prstGeom>
+          <a:noFill/>
+        </p:spPr>
+        <p:txBody>
+          <a:bodyPr wrap="square" anchor="t" tIns="0" bIns="0">
+            <a:spAutoFit/>
+          </a:bodyPr>
+          <a:lstStyle/>
+          <a:p>
+            <a:pPr algn="l"/>
+            <a:r>
               <a:rPr sz="1000" b="0" i="0">
                 <a:solidFill>
-                  <a:srgbClr val="555555"/>
+                  <a:srgbClr val="6E6E69"/>
                 </a:solidFill>
+                <a:latin typeface="Calibri"/>
               </a:rPr>
               <a:t>{{CHART}}</a:t>
             </a:r>
@@ -4225,17 +4331,18 @@
         <p:spPr>
           <a:xfrm>
             <a:off x="0" y="0"/>
-            <a:ext cx="12188952" cy="6858000"/>
+            <a:ext cx="5852160" cy="91440"/>
           </a:xfrm>
           <a:prstGeom prst="rect">
             <a:avLst/>
           </a:prstGeom>
           <a:solidFill>
-            <a:srgbClr val="F0F2F1"/>
+            <a:srgbClr val="C02026"/>
           </a:solidFill>
           <a:ln>
             <a:noFill/>
           </a:ln>
+          <a:effectLst/>
         </p:spPr>
         <p:style>
           <a:lnRef idx="1">
@@ -4267,18 +4374,19 @@
         </p:nvSpPr>
         <p:spPr>
           <a:xfrm>
-            <a:off x="0" y="0"/>
-            <a:ext cx="12188952" cy="960120"/>
+            <a:off x="5852160" y="0"/>
+            <a:ext cx="6336792" cy="91440"/>
           </a:xfrm>
           <a:prstGeom prst="rect">
             <a:avLst/>
           </a:prstGeom>
           <a:solidFill>
-            <a:srgbClr val="2C6E66"/>
+            <a:srgbClr val="3A8B82"/>
           </a:solidFill>
           <a:ln>
             <a:noFill/>
           </a:ln>
+          <a:effectLst/>
         </p:spPr>
         <p:style>
           <a:lnRef idx="1">
@@ -4304,92 +4412,25 @@
       </p:sp>
       <p:sp>
         <p:nvSpPr>
-          <p:cNvPr id="4" name="TextBox 3"/>
-          <p:cNvSpPr txBox="1"/>
-          <p:nvPr/>
-        </p:nvSpPr>
-        <p:spPr>
-          <a:xfrm>
-            <a:off x="274320" y="82296"/>
-            <a:ext cx="11823192" cy="512064"/>
-          </a:xfrm>
-          <a:prstGeom prst="rect">
-            <a:avLst/>
-          </a:prstGeom>
-          <a:noFill/>
-        </p:spPr>
-        <p:txBody>
-          <a:bodyPr wrap="square" anchor="t">
-            <a:spAutoFit/>
-          </a:bodyPr>
-          <a:lstStyle/>
-          <a:p>
-            <a:pPr algn="l"/>
-            <a:r>
-              <a:rPr sz="1700" b="1" i="0">
-                <a:solidFill>
-                  <a:srgbClr val="FFFFFF"/>
-                </a:solidFill>
-              </a:rPr>
-              <a:t>OUR DELIVERY FOOTPRINT IN  {{INDUSTRY_NAME}}</a:t>
-            </a:r>
-          </a:p>
-        </p:txBody>
-      </p:sp>
-      <p:sp>
-        <p:nvSpPr>
-          <p:cNvPr id="5" name="TextBox 4"/>
-          <p:cNvSpPr txBox="1"/>
-          <p:nvPr/>
-        </p:nvSpPr>
-        <p:spPr>
-          <a:xfrm>
-            <a:off x="274320" y="612648"/>
-            <a:ext cx="11823192" cy="292608"/>
-          </a:xfrm>
-          <a:prstGeom prst="rect">
-            <a:avLst/>
-          </a:prstGeom>
-          <a:noFill/>
-        </p:spPr>
-        <p:txBody>
-          <a:bodyPr wrap="square" anchor="t">
-            <a:spAutoFit/>
-          </a:bodyPr>
-          <a:lstStyle/>
-          <a:p>
-            <a:pPr algn="l"/>
-            <a:r>
-              <a:rPr sz="900" b="0" i="1">
-                <a:solidFill>
-                  <a:srgbClr val="CFE7E2"/>
-                </a:solidFill>
-              </a:rPr>
-              <a:t>J2W track record and capability across this industry</a:t>
-            </a:r>
-          </a:p>
-        </p:txBody>
-      </p:sp>
-      <p:sp>
-        <p:nvSpPr>
-          <p:cNvPr id="6" name="Rectangle 5"/>
+          <p:cNvPr id="4" name="Rectangle 3"/>
           <p:cNvSpPr/>
           <p:nvPr/>
         </p:nvSpPr>
         <p:spPr>
           <a:xfrm>
-            <a:off x="182880" y="1051560"/>
-            <a:ext cx="2859786" cy="1280160"/>
+            <a:off x="228600" y="274320"/>
+            <a:ext cx="59436" cy="475488"/>
           </a:xfrm>
           <a:prstGeom prst="rect">
             <a:avLst/>
           </a:prstGeom>
           <a:solidFill>
-            <a:srgbClr val="FFFFFF"/>
+            <a:srgbClr val="C02026"/>
           </a:solidFill>
           <a:ln>
             <a:noFill/>
           </a:ln>
+          <a:effectLst/>
         </p:spPr>
         <p:style>
           <a:lnRef idx="1">
@@ -4415,24 +4456,95 @@
       </p:sp>
       <p:sp>
         <p:nvSpPr>
+          <p:cNvPr id="5" name="TextBox 4"/>
+          <p:cNvSpPr txBox="1"/>
+          <p:nvPr/>
+        </p:nvSpPr>
+        <p:spPr>
+          <a:xfrm>
+            <a:off x="402336" y="237744"/>
+            <a:ext cx="11338560" cy="475488"/>
+          </a:xfrm>
+          <a:prstGeom prst="rect">
+            <a:avLst/>
+          </a:prstGeom>
+          <a:noFill/>
+        </p:spPr>
+        <p:txBody>
+          <a:bodyPr wrap="square" anchor="t" tIns="0" bIns="0">
+            <a:spAutoFit/>
+          </a:bodyPr>
+          <a:lstStyle/>
+          <a:p>
+            <a:pPr algn="l"/>
+            <a:r>
+              <a:rPr sz="2400" b="1" i="0">
+                <a:solidFill>
+                  <a:srgbClr val="111110"/>
+                </a:solidFill>
+                <a:latin typeface="Calibri"/>
+              </a:rPr>
+              <a:t>OUR DELIVERY FOOTPRINT</a:t>
+            </a:r>
+          </a:p>
+        </p:txBody>
+      </p:sp>
+      <p:sp>
+        <p:nvSpPr>
+          <p:cNvPr id="6" name="TextBox 5"/>
+          <p:cNvSpPr txBox="1"/>
+          <p:nvPr/>
+        </p:nvSpPr>
+        <p:spPr>
+          <a:xfrm>
+            <a:off x="402336" y="731520"/>
+            <a:ext cx="11521440" cy="310896"/>
+          </a:xfrm>
+          <a:prstGeom prst="rect">
+            <a:avLst/>
+          </a:prstGeom>
+          <a:noFill/>
+        </p:spPr>
+        <p:txBody>
+          <a:bodyPr wrap="square" anchor="t" tIns="0" bIns="0">
+            <a:spAutoFit/>
+          </a:bodyPr>
+          <a:lstStyle/>
+          <a:p>
+            <a:pPr algn="l"/>
+            <a:r>
+              <a:rPr sz="1400" b="1" i="0">
+                <a:solidFill>
+                  <a:srgbClr val="3A8B82"/>
+                </a:solidFill>
+                <a:latin typeface="Calibri"/>
+              </a:rPr>
+              <a:t>INDUSTRY:  {{INDUSTRY_NAME}}</a:t>
+            </a:r>
+          </a:p>
+        </p:txBody>
+      </p:sp>
+      <p:sp>
+        <p:nvSpPr>
           <p:cNvPr id="7" name="Rectangle 6"/>
           <p:cNvSpPr/>
           <p:nvPr/>
         </p:nvSpPr>
         <p:spPr>
           <a:xfrm>
-            <a:off x="182880" y="1051560"/>
-            <a:ext cx="2859786" cy="45720"/>
+            <a:off x="0" y="6766560"/>
+            <a:ext cx="12188952" cy="91440"/>
           </a:xfrm>
           <a:prstGeom prst="rect">
             <a:avLst/>
           </a:prstGeom>
           <a:solidFill>
-            <a:srgbClr val="2C6E66"/>
+            <a:srgbClr val="3A8B82"/>
           </a:solidFill>
           <a:ln>
             <a:noFill/>
           </a:ln>
+          <a:effectLst/>
         </p:spPr>
         <p:style>
           <a:lnRef idx="1">
@@ -4458,82 +4570,14 @@
       </p:sp>
       <p:sp>
         <p:nvSpPr>
-          <p:cNvPr id="8" name="TextBox 7"/>
-          <p:cNvSpPr txBox="1"/>
-          <p:nvPr/>
-        </p:nvSpPr>
-        <p:spPr>
-          <a:xfrm>
-            <a:off x="320040" y="1143000"/>
-            <a:ext cx="2585466" cy="621792"/>
-          </a:xfrm>
-          <a:prstGeom prst="rect">
-            <a:avLst/>
-          </a:prstGeom>
-          <a:noFill/>
-        </p:spPr>
-        <p:txBody>
-          <a:bodyPr wrap="square" anchor="t">
-            <a:spAutoFit/>
-          </a:bodyPr>
-          <a:lstStyle/>
-          <a:p>
-            <a:pPr algn="ctr"/>
-            <a:r>
-              <a:rPr sz="2600" b="1" i="0">
-                <a:solidFill>
-                  <a:srgbClr val="2C6E66"/>
-                </a:solidFill>
-              </a:rPr>
-              <a:t>{{TOTAL_CONSULTANTS}}</a:t>
-            </a:r>
-          </a:p>
-        </p:txBody>
-      </p:sp>
-      <p:sp>
-        <p:nvSpPr>
-          <p:cNvPr id="9" name="TextBox 8"/>
-          <p:cNvSpPr txBox="1"/>
-          <p:nvPr/>
-        </p:nvSpPr>
-        <p:spPr>
-          <a:xfrm>
-            <a:off x="320040" y="1783080"/>
-            <a:ext cx="2585466" cy="475488"/>
-          </a:xfrm>
-          <a:prstGeom prst="rect">
-            <a:avLst/>
-          </a:prstGeom>
-          <a:noFill/>
-        </p:spPr>
-        <p:txBody>
-          <a:bodyPr wrap="square" anchor="t">
-            <a:spAutoFit/>
-          </a:bodyPr>
-          <a:lstStyle/>
-          <a:p>
-            <a:pPr algn="ctr"/>
-            <a:r>
-              <a:rPr sz="900" b="0" i="0">
-                <a:solidFill>
-                  <a:srgbClr val="555555"/>
-                </a:solidFill>
-              </a:rPr>
-              <a:t>Consultants deployed</a:t>
-            </a:r>
-          </a:p>
-        </p:txBody>
-      </p:sp>
-      <p:sp>
-        <p:nvSpPr>
-          <p:cNvPr id="10" name="Rectangle 9"/>
+          <p:cNvPr id="8" name="Rectangle 7"/>
           <p:cNvSpPr/>
           <p:nvPr/>
         </p:nvSpPr>
         <p:spPr>
           <a:xfrm>
-            <a:off x="3170682" y="1051560"/>
-            <a:ext cx="2859786" cy="1280160"/>
+            <a:off x="274320" y="1188720"/>
+            <a:ext cx="2786634" cy="1170432"/>
           </a:xfrm>
           <a:prstGeom prst="rect">
             <a:avLst/>
@@ -4541,9 +4585,12 @@
           <a:solidFill>
             <a:srgbClr val="FFFFFF"/>
           </a:solidFill>
-          <a:ln>
-            <a:noFill/>
+          <a:ln w="9525">
+            <a:solidFill>
+              <a:srgbClr val="DEDEDE"/>
+            </a:solidFill>
           </a:ln>
+          <a:effectLst/>
         </p:spPr>
         <p:style>
           <a:lnRef idx="1">
@@ -4569,24 +4616,25 @@
       </p:sp>
       <p:sp>
         <p:nvSpPr>
-          <p:cNvPr id="11" name="Rectangle 10"/>
+          <p:cNvPr id="9" name="Rectangle 8"/>
           <p:cNvSpPr/>
           <p:nvPr/>
         </p:nvSpPr>
         <p:spPr>
           <a:xfrm>
-            <a:off x="3170682" y="1051560"/>
-            <a:ext cx="2859786" cy="45720"/>
+            <a:off x="274320" y="1188720"/>
+            <a:ext cx="2786634" cy="45720"/>
           </a:xfrm>
           <a:prstGeom prst="rect">
             <a:avLst/>
           </a:prstGeom>
           <a:solidFill>
-            <a:srgbClr val="2C6E66"/>
+            <a:srgbClr val="3A8B82"/>
           </a:solidFill>
           <a:ln>
             <a:noFill/>
           </a:ln>
+          <a:effectLst/>
         </p:spPr>
         <p:style>
           <a:lnRef idx="1">
@@ -4612,14 +4660,14 @@
       </p:sp>
       <p:sp>
         <p:nvSpPr>
-          <p:cNvPr id="12" name="TextBox 11"/>
+          <p:cNvPr id="10" name="TextBox 9"/>
           <p:cNvSpPr txBox="1"/>
           <p:nvPr/>
         </p:nvSpPr>
         <p:spPr>
           <a:xfrm>
-            <a:off x="3307842" y="1143000"/>
-            <a:ext cx="2585466" cy="621792"/>
+            <a:off x="347472" y="1371600"/>
+            <a:ext cx="2640330" cy="603504"/>
           </a:xfrm>
           <a:prstGeom prst="rect">
             <a:avLst/>
@@ -4627,33 +4675,34 @@
           <a:noFill/>
         </p:spPr>
         <p:txBody>
-          <a:bodyPr wrap="square" anchor="t">
+          <a:bodyPr wrap="square" anchor="t" tIns="0" bIns="0">
             <a:spAutoFit/>
           </a:bodyPr>
           <a:lstStyle/>
           <a:p>
             <a:pPr algn="ctr"/>
             <a:r>
-              <a:rPr sz="2600" b="1" i="0">
+              <a:rPr sz="2700" b="1" i="0">
                 <a:solidFill>
-                  <a:srgbClr val="2C6E66"/>
+                  <a:srgbClr val="3A8B82"/>
                 </a:solidFill>
+                <a:latin typeface="Calibri"/>
               </a:rPr>
-              <a:t>{{NUM_COMPANIES}}</a:t>
-            </a:r>
-          </a:p>
-        </p:txBody>
-      </p:sp>
-      <p:sp>
-        <p:nvSpPr>
-          <p:cNvPr id="13" name="TextBox 12"/>
+              <a:t>{{TOTAL_CONSULTANTS}}</a:t>
+            </a:r>
+          </a:p>
+        </p:txBody>
+      </p:sp>
+      <p:sp>
+        <p:nvSpPr>
+          <p:cNvPr id="11" name="TextBox 10"/>
           <p:cNvSpPr txBox="1"/>
           <p:nvPr/>
         </p:nvSpPr>
         <p:spPr>
           <a:xfrm>
-            <a:off x="3307842" y="1783080"/>
-            <a:ext cx="2585466" cy="475488"/>
+            <a:off x="347472" y="2011680"/>
+            <a:ext cx="2640330" cy="292608"/>
           </a:xfrm>
           <a:prstGeom prst="rect">
             <a:avLst/>
@@ -4661,7 +4710,7 @@
           <a:noFill/>
         </p:spPr>
         <p:txBody>
-          <a:bodyPr wrap="square" anchor="t">
+          <a:bodyPr wrap="square" anchor="t" tIns="0" bIns="0">
             <a:spAutoFit/>
           </a:bodyPr>
           <a:lstStyle/>
@@ -4670,24 +4719,25 @@
             <a:r>
               <a:rPr sz="900" b="0" i="0">
                 <a:solidFill>
-                  <a:srgbClr val="555555"/>
+                  <a:srgbClr val="6E6E69"/>
                 </a:solidFill>
+                <a:latin typeface="Calibri"/>
               </a:rPr>
-              <a:t>Companies served</a:t>
-            </a:r>
-          </a:p>
-        </p:txBody>
-      </p:sp>
-      <p:sp>
-        <p:nvSpPr>
-          <p:cNvPr id="14" name="Rectangle 13"/>
+              <a:t>Consultants deployed</a:t>
+            </a:r>
+          </a:p>
+        </p:txBody>
+      </p:sp>
+      <p:sp>
+        <p:nvSpPr>
+          <p:cNvPr id="12" name="Rectangle 11"/>
           <p:cNvSpPr/>
           <p:nvPr/>
         </p:nvSpPr>
         <p:spPr>
           <a:xfrm>
-            <a:off x="6158484" y="1051560"/>
-            <a:ext cx="2859786" cy="1280160"/>
+            <a:off x="3225546" y="1188720"/>
+            <a:ext cx="2786634" cy="1170432"/>
           </a:xfrm>
           <a:prstGeom prst="rect">
             <a:avLst/>
@@ -4695,9 +4745,12 @@
           <a:solidFill>
             <a:srgbClr val="FFFFFF"/>
           </a:solidFill>
-          <a:ln>
-            <a:noFill/>
+          <a:ln w="9525">
+            <a:solidFill>
+              <a:srgbClr val="DEDEDE"/>
+            </a:solidFill>
           </a:ln>
+          <a:effectLst/>
         </p:spPr>
         <p:style>
           <a:lnRef idx="1">
@@ -4723,24 +4776,25 @@
       </p:sp>
       <p:sp>
         <p:nvSpPr>
-          <p:cNvPr id="15" name="Rectangle 14"/>
+          <p:cNvPr id="13" name="Rectangle 12"/>
           <p:cNvSpPr/>
           <p:nvPr/>
         </p:nvSpPr>
         <p:spPr>
           <a:xfrm>
-            <a:off x="6158484" y="1051560"/>
-            <a:ext cx="2859786" cy="45720"/>
+            <a:off x="3225546" y="1188720"/>
+            <a:ext cx="2786634" cy="45720"/>
           </a:xfrm>
           <a:prstGeom prst="rect">
             <a:avLst/>
           </a:prstGeom>
           <a:solidFill>
-            <a:srgbClr val="2C6E66"/>
+            <a:srgbClr val="3A8B82"/>
           </a:solidFill>
           <a:ln>
             <a:noFill/>
           </a:ln>
+          <a:effectLst/>
         </p:spPr>
         <p:style>
           <a:lnRef idx="1">
@@ -4766,14 +4820,14 @@
       </p:sp>
       <p:sp>
         <p:nvSpPr>
-          <p:cNvPr id="16" name="TextBox 15"/>
+          <p:cNvPr id="14" name="TextBox 13"/>
           <p:cNvSpPr txBox="1"/>
           <p:nvPr/>
         </p:nvSpPr>
         <p:spPr>
           <a:xfrm>
-            <a:off x="6295644" y="1143000"/>
-            <a:ext cx="2585466" cy="621792"/>
+            <a:off x="3298698" y="1371600"/>
+            <a:ext cx="2640330" cy="603504"/>
           </a:xfrm>
           <a:prstGeom prst="rect">
             <a:avLst/>
@@ -4781,33 +4835,34 @@
           <a:noFill/>
         </p:spPr>
         <p:txBody>
-          <a:bodyPr wrap="square" anchor="t">
+          <a:bodyPr wrap="square" anchor="t" tIns="0" bIns="0">
             <a:spAutoFit/>
           </a:bodyPr>
           <a:lstStyle/>
           <a:p>
             <a:pPr algn="ctr"/>
             <a:r>
-              <a:rPr sz="2600" b="1" i="0">
+              <a:rPr sz="2700" b="1" i="0">
                 <a:solidFill>
-                  <a:srgbClr val="2C6E66"/>
+                  <a:srgbClr val="3A8B82"/>
                 </a:solidFill>
+                <a:latin typeface="Calibri"/>
               </a:rPr>
-              <a:t>{{NUM_FUNCTIONS}}</a:t>
-            </a:r>
-          </a:p>
-        </p:txBody>
-      </p:sp>
-      <p:sp>
-        <p:nvSpPr>
-          <p:cNvPr id="17" name="TextBox 16"/>
+              <a:t>{{NUM_COMPANIES}}</a:t>
+            </a:r>
+          </a:p>
+        </p:txBody>
+      </p:sp>
+      <p:sp>
+        <p:nvSpPr>
+          <p:cNvPr id="15" name="TextBox 14"/>
           <p:cNvSpPr txBox="1"/>
           <p:nvPr/>
         </p:nvSpPr>
         <p:spPr>
           <a:xfrm>
-            <a:off x="6295644" y="1783080"/>
-            <a:ext cx="2585466" cy="475488"/>
+            <a:off x="3298698" y="2011680"/>
+            <a:ext cx="2640330" cy="292608"/>
           </a:xfrm>
           <a:prstGeom prst="rect">
             <a:avLst/>
@@ -4815,7 +4870,7 @@
           <a:noFill/>
         </p:spPr>
         <p:txBody>
-          <a:bodyPr wrap="square" anchor="t">
+          <a:bodyPr wrap="square" anchor="t" tIns="0" bIns="0">
             <a:spAutoFit/>
           </a:bodyPr>
           <a:lstStyle/>
@@ -4824,24 +4879,25 @@
             <a:r>
               <a:rPr sz="900" b="0" i="0">
                 <a:solidFill>
-                  <a:srgbClr val="555555"/>
+                  <a:srgbClr val="6E6E69"/>
                 </a:solidFill>
+                <a:latin typeface="Calibri"/>
               </a:rPr>
-              <a:t>Functions delivered</a:t>
-            </a:r>
-          </a:p>
-        </p:txBody>
-      </p:sp>
-      <p:sp>
-        <p:nvSpPr>
-          <p:cNvPr id="18" name="Rectangle 17"/>
+              <a:t>Companies served</a:t>
+            </a:r>
+          </a:p>
+        </p:txBody>
+      </p:sp>
+      <p:sp>
+        <p:nvSpPr>
+          <p:cNvPr id="16" name="Rectangle 15"/>
           <p:cNvSpPr/>
           <p:nvPr/>
         </p:nvSpPr>
         <p:spPr>
           <a:xfrm>
-            <a:off x="9146286" y="1051560"/>
-            <a:ext cx="2859786" cy="1280160"/>
+            <a:off x="6176772" y="1188720"/>
+            <a:ext cx="2786634" cy="1170432"/>
           </a:xfrm>
           <a:prstGeom prst="rect">
             <a:avLst/>
@@ -4849,9 +4905,12 @@
           <a:solidFill>
             <a:srgbClr val="FFFFFF"/>
           </a:solidFill>
-          <a:ln>
-            <a:noFill/>
+          <a:ln w="9525">
+            <a:solidFill>
+              <a:srgbClr val="DEDEDE"/>
+            </a:solidFill>
           </a:ln>
+          <a:effectLst/>
         </p:spPr>
         <p:style>
           <a:lnRef idx="1">
@@ -4877,24 +4936,25 @@
       </p:sp>
       <p:sp>
         <p:nvSpPr>
-          <p:cNvPr id="19" name="Rectangle 18"/>
+          <p:cNvPr id="17" name="Rectangle 16"/>
           <p:cNvSpPr/>
           <p:nvPr/>
         </p:nvSpPr>
         <p:spPr>
           <a:xfrm>
-            <a:off x="9146286" y="1051560"/>
-            <a:ext cx="2859786" cy="45720"/>
+            <a:off x="6176772" y="1188720"/>
+            <a:ext cx="2786634" cy="45720"/>
           </a:xfrm>
           <a:prstGeom prst="rect">
             <a:avLst/>
           </a:prstGeom>
           <a:solidFill>
-            <a:srgbClr val="2C6E66"/>
+            <a:srgbClr val="3A8B82"/>
           </a:solidFill>
           <a:ln>
             <a:noFill/>
           </a:ln>
+          <a:effectLst/>
         </p:spPr>
         <p:style>
           <a:lnRef idx="1">
@@ -4920,14 +4980,14 @@
       </p:sp>
       <p:sp>
         <p:nvSpPr>
-          <p:cNvPr id="20" name="TextBox 19"/>
+          <p:cNvPr id="18" name="TextBox 17"/>
           <p:cNvSpPr txBox="1"/>
           <p:nvPr/>
         </p:nvSpPr>
         <p:spPr>
           <a:xfrm>
-            <a:off x="9283446" y="1143000"/>
-            <a:ext cx="2585466" cy="621792"/>
+            <a:off x="6249924" y="1371600"/>
+            <a:ext cx="2640330" cy="603504"/>
           </a:xfrm>
           <a:prstGeom prst="rect">
             <a:avLst/>
@@ -4935,33 +4995,34 @@
           <a:noFill/>
         </p:spPr>
         <p:txBody>
-          <a:bodyPr wrap="square" anchor="t">
+          <a:bodyPr wrap="square" anchor="t" tIns="0" bIns="0">
             <a:spAutoFit/>
           </a:bodyPr>
           <a:lstStyle/>
           <a:p>
             <a:pPr algn="ctr"/>
             <a:r>
-              <a:rPr sz="2600" b="1" i="0">
+              <a:rPr sz="2700" b="1" i="0">
                 <a:solidFill>
-                  <a:srgbClr val="2C6E66"/>
+                  <a:srgbClr val="3A8B82"/>
                 </a:solidFill>
+                <a:latin typeface="Calibri"/>
               </a:rPr>
-              <a:t>{{NUM_SKILLS}}</a:t>
-            </a:r>
-          </a:p>
-        </p:txBody>
-      </p:sp>
-      <p:sp>
-        <p:nvSpPr>
-          <p:cNvPr id="21" name="TextBox 20"/>
+              <a:t>{{NUM_FUNCTIONS}}</a:t>
+            </a:r>
+          </a:p>
+        </p:txBody>
+      </p:sp>
+      <p:sp>
+        <p:nvSpPr>
+          <p:cNvPr id="19" name="TextBox 18"/>
           <p:cNvSpPr txBox="1"/>
           <p:nvPr/>
         </p:nvSpPr>
         <p:spPr>
           <a:xfrm>
-            <a:off x="9283446" y="1783080"/>
-            <a:ext cx="2585466" cy="475488"/>
+            <a:off x="6249924" y="2011680"/>
+            <a:ext cx="2640330" cy="292608"/>
           </a:xfrm>
           <a:prstGeom prst="rect">
             <a:avLst/>
@@ -4969,7 +5030,7 @@
           <a:noFill/>
         </p:spPr>
         <p:txBody>
-          <a:bodyPr wrap="square" anchor="t">
+          <a:bodyPr wrap="square" anchor="t" tIns="0" bIns="0">
             <a:spAutoFit/>
           </a:bodyPr>
           <a:lstStyle/>
@@ -4978,34 +5039,38 @@
             <a:r>
               <a:rPr sz="900" b="0" i="0">
                 <a:solidFill>
-                  <a:srgbClr val="555555"/>
+                  <a:srgbClr val="6E6E69"/>
                 </a:solidFill>
+                <a:latin typeface="Calibri"/>
               </a:rPr>
-              <a:t>Distinct skills deployed</a:t>
-            </a:r>
-          </a:p>
-        </p:txBody>
-      </p:sp>
-      <p:sp>
-        <p:nvSpPr>
-          <p:cNvPr id="22" name="Rectangle 21"/>
+              <a:t>Functions delivered</a:t>
+            </a:r>
+          </a:p>
+        </p:txBody>
+      </p:sp>
+      <p:sp>
+        <p:nvSpPr>
+          <p:cNvPr id="20" name="Rectangle 19"/>
           <p:cNvSpPr/>
           <p:nvPr/>
         </p:nvSpPr>
         <p:spPr>
           <a:xfrm>
-            <a:off x="182880" y="2404872"/>
-            <a:ext cx="11823192" cy="20116"/>
+            <a:off x="9127998" y="1188720"/>
+            <a:ext cx="2786634" cy="1170432"/>
           </a:xfrm>
           <a:prstGeom prst="rect">
             <a:avLst/>
           </a:prstGeom>
           <a:solidFill>
-            <a:srgbClr val="7FB2A9"/>
+            <a:srgbClr val="FFFFFF"/>
           </a:solidFill>
-          <a:ln>
-            <a:noFill/>
+          <a:ln w="9525">
+            <a:solidFill>
+              <a:srgbClr val="DEDEDE"/>
+            </a:solidFill>
           </a:ln>
+          <a:effectLst/>
         </p:spPr>
         <p:style>
           <a:lnRef idx="1">
@@ -5031,24 +5096,25 @@
       </p:sp>
       <p:sp>
         <p:nvSpPr>
-          <p:cNvPr id="23" name="Rectangle 22"/>
+          <p:cNvPr id="21" name="Rectangle 20"/>
           <p:cNvSpPr/>
           <p:nvPr/>
         </p:nvSpPr>
         <p:spPr>
           <a:xfrm>
-            <a:off x="182880" y="2496312"/>
-            <a:ext cx="5074920" cy="4270248"/>
+            <a:off x="9127998" y="1188720"/>
+            <a:ext cx="2786634" cy="45720"/>
           </a:xfrm>
           <a:prstGeom prst="rect">
             <a:avLst/>
           </a:prstGeom>
           <a:solidFill>
-            <a:srgbClr val="FFFFFF"/>
+            <a:srgbClr val="3A8B82"/>
           </a:solidFill>
           <a:ln>
             <a:noFill/>
           </a:ln>
+          <a:effectLst/>
         </p:spPr>
         <p:style>
           <a:lnRef idx="1">
@@ -5074,24 +5140,97 @@
       </p:sp>
       <p:sp>
         <p:nvSpPr>
+          <p:cNvPr id="22" name="TextBox 21"/>
+          <p:cNvSpPr txBox="1"/>
+          <p:nvPr/>
+        </p:nvSpPr>
+        <p:spPr>
+          <a:xfrm>
+            <a:off x="9201150" y="1371600"/>
+            <a:ext cx="2640330" cy="603504"/>
+          </a:xfrm>
+          <a:prstGeom prst="rect">
+            <a:avLst/>
+          </a:prstGeom>
+          <a:noFill/>
+        </p:spPr>
+        <p:txBody>
+          <a:bodyPr wrap="square" anchor="t" tIns="0" bIns="0">
+            <a:spAutoFit/>
+          </a:bodyPr>
+          <a:lstStyle/>
+          <a:p>
+            <a:pPr algn="ctr"/>
+            <a:r>
+              <a:rPr sz="2700" b="1" i="0">
+                <a:solidFill>
+                  <a:srgbClr val="3A8B82"/>
+                </a:solidFill>
+                <a:latin typeface="Calibri"/>
+              </a:rPr>
+              <a:t>{{NUM_SKILLS}}</a:t>
+            </a:r>
+          </a:p>
+        </p:txBody>
+      </p:sp>
+      <p:sp>
+        <p:nvSpPr>
+          <p:cNvPr id="23" name="TextBox 22"/>
+          <p:cNvSpPr txBox="1"/>
+          <p:nvPr/>
+        </p:nvSpPr>
+        <p:spPr>
+          <a:xfrm>
+            <a:off x="9201150" y="2011680"/>
+            <a:ext cx="2640330" cy="292608"/>
+          </a:xfrm>
+          <a:prstGeom prst="rect">
+            <a:avLst/>
+          </a:prstGeom>
+          <a:noFill/>
+        </p:spPr>
+        <p:txBody>
+          <a:bodyPr wrap="square" anchor="t" tIns="0" bIns="0">
+            <a:spAutoFit/>
+          </a:bodyPr>
+          <a:lstStyle/>
+          <a:p>
+            <a:pPr algn="ctr"/>
+            <a:r>
+              <a:rPr sz="900" b="0" i="0">
+                <a:solidFill>
+                  <a:srgbClr val="6E6E69"/>
+                </a:solidFill>
+                <a:latin typeface="Calibri"/>
+              </a:rPr>
+              <a:t>Distinct skills</a:t>
+            </a:r>
+          </a:p>
+        </p:txBody>
+      </p:sp>
+      <p:sp>
+        <p:nvSpPr>
           <p:cNvPr id="24" name="Rectangle 23"/>
           <p:cNvSpPr/>
           <p:nvPr/>
         </p:nvSpPr>
         <p:spPr>
           <a:xfrm>
-            <a:off x="182880" y="2496312"/>
-            <a:ext cx="45720" cy="4270248"/>
+            <a:off x="274320" y="2560320"/>
+            <a:ext cx="5074920" cy="4041647"/>
           </a:xfrm>
           <a:prstGeom prst="rect">
             <a:avLst/>
           </a:prstGeom>
           <a:solidFill>
-            <a:srgbClr val="2C6E66"/>
+            <a:srgbClr val="FFFFFF"/>
           </a:solidFill>
-          <a:ln>
-            <a:noFill/>
+          <a:ln w="9525">
+            <a:solidFill>
+              <a:srgbClr val="DEDEDE"/>
+            </a:solidFill>
           </a:ln>
+          <a:effectLst/>
         </p:spPr>
         <p:style>
           <a:lnRef idx="1">
@@ -5117,58 +5256,25 @@
       </p:sp>
       <p:sp>
         <p:nvSpPr>
-          <p:cNvPr id="25" name="TextBox 24"/>
-          <p:cNvSpPr txBox="1"/>
-          <p:nvPr/>
-        </p:nvSpPr>
-        <p:spPr>
-          <a:xfrm>
-            <a:off x="320040" y="2633472"/>
-            <a:ext cx="4800600" cy="256032"/>
-          </a:xfrm>
-          <a:prstGeom prst="rect">
-            <a:avLst/>
-          </a:prstGeom>
-          <a:noFill/>
-        </p:spPr>
-        <p:txBody>
-          <a:bodyPr wrap="square" anchor="t">
-            <a:spAutoFit/>
-          </a:bodyPr>
-          <a:lstStyle/>
-          <a:p>
-            <a:pPr algn="l"/>
-            <a:r>
-              <a:rPr sz="1100" b="1" i="0">
-                <a:solidFill>
-                  <a:srgbClr val="2C6E66"/>
-                </a:solidFill>
-              </a:rPr>
-              <a:t>TOP HIRED SKILLS  —  BY COMPANIES SERVED</a:t>
-            </a:r>
-          </a:p>
-        </p:txBody>
-      </p:sp>
-      <p:sp>
-        <p:nvSpPr>
-          <p:cNvPr id="26" name="Rectangle 25"/>
+          <p:cNvPr id="25" name="Rectangle 24"/>
           <p:cNvSpPr/>
           <p:nvPr/>
         </p:nvSpPr>
         <p:spPr>
           <a:xfrm>
-            <a:off x="320040" y="2926079"/>
-            <a:ext cx="4800600" cy="20116"/>
+            <a:off x="274320" y="2560320"/>
+            <a:ext cx="54864" cy="4041647"/>
           </a:xfrm>
           <a:prstGeom prst="rect">
             <a:avLst/>
           </a:prstGeom>
           <a:solidFill>
-            <a:srgbClr val="7FB2A9"/>
+            <a:srgbClr val="C02026"/>
           </a:solidFill>
           <a:ln>
             <a:noFill/>
           </a:ln>
+          <a:effectLst/>
         </p:spPr>
         <p:style>
           <a:lnRef idx="1">
@@ -5194,24 +5300,60 @@
       </p:sp>
       <p:sp>
         <p:nvSpPr>
+          <p:cNvPr id="26" name="TextBox 25"/>
+          <p:cNvSpPr txBox="1"/>
+          <p:nvPr/>
+        </p:nvSpPr>
+        <p:spPr>
+          <a:xfrm>
+            <a:off x="420623" y="2706624"/>
+            <a:ext cx="4782312" cy="256032"/>
+          </a:xfrm>
+          <a:prstGeom prst="rect">
+            <a:avLst/>
+          </a:prstGeom>
+          <a:noFill/>
+        </p:spPr>
+        <p:txBody>
+          <a:bodyPr wrap="square" anchor="t" tIns="0" bIns="0">
+            <a:spAutoFit/>
+          </a:bodyPr>
+          <a:lstStyle/>
+          <a:p>
+            <a:pPr algn="l"/>
+            <a:r>
+              <a:rPr sz="1100" b="1" i="0">
+                <a:solidFill>
+                  <a:srgbClr val="3A8B82"/>
+                </a:solidFill>
+                <a:latin typeface="Calibri"/>
+              </a:rPr>
+              <a:t>TOP HIRED SKILLS - BY COMPANIES SERVED</a:t>
+            </a:r>
+          </a:p>
+        </p:txBody>
+      </p:sp>
+      <p:sp>
+        <p:nvSpPr>
           <p:cNvPr id="27" name="Rectangle 26"/>
           <p:cNvSpPr/>
           <p:nvPr/>
         </p:nvSpPr>
         <p:spPr>
           <a:xfrm>
-            <a:off x="320040" y="2999232"/>
-            <a:ext cx="4800600" cy="1155192"/>
+            <a:off x="420623" y="2980944"/>
+            <a:ext cx="4782312" cy="20116"/>
           </a:xfrm>
           <a:prstGeom prst="rect">
             <a:avLst/>
           </a:prstGeom>
           <a:solidFill>
-            <a:srgbClr val="CFE7E2"/>
+            <a:srgbClr val="3A8B82"/>
           </a:solidFill>
           <a:ln>
             <a:noFill/>
           </a:ln>
+          <a:effectLst/>
         </p:spPr>
         <p:style>
           <a:lnRef idx="1">
@@ -5243,18 +5385,21 @@
         </p:nvSpPr>
         <p:spPr>
           <a:xfrm>
-            <a:off x="320040" y="2999232"/>
-            <a:ext cx="402336" cy="1155192"/>
+            <a:off x="420623" y="3127248"/>
+            <a:ext cx="4782312" cy="1072895"/>
           </a:xfrm>
           <a:prstGeom prst="rect">
             <a:avLst/>
           </a:prstGeom>
           <a:solidFill>
-            <a:srgbClr val="2C6E66"/>
+            <a:srgbClr val="F5F5F5"/>
           </a:solidFill>
-          <a:ln>
-            <a:noFill/>
+          <a:ln w="9525">
+            <a:solidFill>
+              <a:srgbClr val="DEDEDE"/>
+            </a:solidFill>
           </a:ln>
+          <a:effectLst/>
         </p:spPr>
         <p:style>
           <a:lnRef idx="1">
@@ -5280,92 +5425,25 @@
       </p:sp>
       <p:sp>
         <p:nvSpPr>
-          <p:cNvPr id="29" name="TextBox 28"/>
-          <p:cNvSpPr txBox="1"/>
-          <p:nvPr/>
-        </p:nvSpPr>
-        <p:spPr>
-          <a:xfrm>
-            <a:off x="320040" y="2999232"/>
-            <a:ext cx="402336" cy="1155192"/>
-          </a:xfrm>
-          <a:prstGeom prst="rect">
-            <a:avLst/>
-          </a:prstGeom>
-          <a:noFill/>
-        </p:spPr>
-        <p:txBody>
-          <a:bodyPr wrap="square" anchor="ctr">
-            <a:spAutoFit/>
-          </a:bodyPr>
-          <a:lstStyle/>
-          <a:p>
-            <a:pPr algn="ctr"/>
-            <a:r>
-              <a:rPr sz="1300" b="1" i="0">
-                <a:solidFill>
-                  <a:srgbClr val="FFFFFF"/>
-                </a:solidFill>
-              </a:rPr>
-              <a:t>#1</a:t>
-            </a:r>
-          </a:p>
-        </p:txBody>
-      </p:sp>
-      <p:sp>
-        <p:nvSpPr>
-          <p:cNvPr id="30" name="TextBox 29"/>
-          <p:cNvSpPr txBox="1"/>
-          <p:nvPr/>
-        </p:nvSpPr>
-        <p:spPr>
-          <a:xfrm>
-            <a:off x="813816" y="3072384"/>
-            <a:ext cx="4270248" cy="1008888"/>
-          </a:xfrm>
-          <a:prstGeom prst="rect">
-            <a:avLst/>
-          </a:prstGeom>
-          <a:noFill/>
-        </p:spPr>
-        <p:txBody>
-          <a:bodyPr wrap="square" anchor="t">
-            <a:spAutoFit/>
-          </a:bodyPr>
-          <a:lstStyle/>
-          <a:p>
-            <a:pPr algn="l"/>
-            <a:r>
-              <a:rPr sz="1100" b="0" i="0">
-                <a:solidFill>
-                  <a:srgbClr val="111110"/>
-                </a:solidFill>
-              </a:rPr>
-              <a:t>{{TOP_SKILL_1}}</a:t>
-            </a:r>
-          </a:p>
-        </p:txBody>
-      </p:sp>
-      <p:sp>
-        <p:nvSpPr>
-          <p:cNvPr id="31" name="Rectangle 30"/>
+          <p:cNvPr id="29" name="Rectangle 28"/>
           <p:cNvSpPr/>
           <p:nvPr/>
         </p:nvSpPr>
         <p:spPr>
           <a:xfrm>
-            <a:off x="320040" y="4236720"/>
-            <a:ext cx="4800600" cy="1155192"/>
+            <a:off x="420623" y="3127248"/>
+            <a:ext cx="420624" cy="1072895"/>
           </a:xfrm>
           <a:prstGeom prst="rect">
             <a:avLst/>
           </a:prstGeom>
           <a:solidFill>
-            <a:srgbClr val="CFE7E2"/>
+            <a:srgbClr val="C02026"/>
           </a:solidFill>
           <a:ln>
             <a:noFill/>
           </a:ln>
+          <a:effectLst/>
         </p:spPr>
         <p:style>
           <a:lnRef idx="1">
@@ -5391,24 +5469,97 @@
       </p:sp>
       <p:sp>
         <p:nvSpPr>
+          <p:cNvPr id="30" name="TextBox 29"/>
+          <p:cNvSpPr txBox="1"/>
+          <p:nvPr/>
+        </p:nvSpPr>
+        <p:spPr>
+          <a:xfrm>
+            <a:off x="420623" y="3127248"/>
+            <a:ext cx="420624" cy="1072895"/>
+          </a:xfrm>
+          <a:prstGeom prst="rect">
+            <a:avLst/>
+          </a:prstGeom>
+          <a:noFill/>
+        </p:spPr>
+        <p:txBody>
+          <a:bodyPr wrap="square" anchor="ctr" tIns="0" bIns="0">
+            <a:spAutoFit/>
+          </a:bodyPr>
+          <a:lstStyle/>
+          <a:p>
+            <a:pPr algn="ctr"/>
+            <a:r>
+              <a:rPr sz="1400" b="1" i="0">
+                <a:solidFill>
+                  <a:srgbClr val="FFFFFF"/>
+                </a:solidFill>
+                <a:latin typeface="Calibri"/>
+              </a:rPr>
+              <a:t>#1</a:t>
+            </a:r>
+          </a:p>
+        </p:txBody>
+      </p:sp>
+      <p:sp>
+        <p:nvSpPr>
+          <p:cNvPr id="31" name="TextBox 30"/>
+          <p:cNvSpPr txBox="1"/>
+          <p:nvPr/>
+        </p:nvSpPr>
+        <p:spPr>
+          <a:xfrm>
+            <a:off x="950976" y="3182112"/>
+            <a:ext cx="4197096" cy="963167"/>
+          </a:xfrm>
+          <a:prstGeom prst="rect">
+            <a:avLst/>
+          </a:prstGeom>
+          <a:noFill/>
+        </p:spPr>
+        <p:txBody>
+          <a:bodyPr wrap="square" anchor="ctr" tIns="0" bIns="0">
+            <a:spAutoFit/>
+          </a:bodyPr>
+          <a:lstStyle/>
+          <a:p>
+            <a:pPr algn="l"/>
+            <a:r>
+              <a:rPr sz="1100" b="0" i="0">
+                <a:solidFill>
+                  <a:srgbClr val="3E3E3E"/>
+                </a:solidFill>
+                <a:latin typeface="Calibri"/>
+              </a:rPr>
+              <a:t>{{TOP_SKILL_1}}</a:t>
+            </a:r>
+          </a:p>
+        </p:txBody>
+      </p:sp>
+      <p:sp>
+        <p:nvSpPr>
           <p:cNvPr id="32" name="Rectangle 31"/>
           <p:cNvSpPr/>
           <p:nvPr/>
         </p:nvSpPr>
         <p:spPr>
           <a:xfrm>
-            <a:off x="320040" y="4236720"/>
-            <a:ext cx="402336" cy="1155192"/>
+            <a:off x="420623" y="4291584"/>
+            <a:ext cx="4782312" cy="1072895"/>
           </a:xfrm>
           <a:prstGeom prst="rect">
             <a:avLst/>
           </a:prstGeom>
           <a:solidFill>
-            <a:srgbClr val="2C6E66"/>
+            <a:srgbClr val="F5F5F5"/>
           </a:solidFill>
-          <a:ln>
-            <a:noFill/>
+          <a:ln w="9525">
+            <a:solidFill>
+              <a:srgbClr val="DEDEDE"/>
+            </a:solidFill>
           </a:ln>
+          <a:effectLst/>
         </p:spPr>
         <p:style>
           <a:lnRef idx="1">
@@ -5434,92 +5585,25 @@
       </p:sp>
       <p:sp>
         <p:nvSpPr>
-          <p:cNvPr id="33" name="TextBox 32"/>
-          <p:cNvSpPr txBox="1"/>
-          <p:nvPr/>
-        </p:nvSpPr>
-        <p:spPr>
-          <a:xfrm>
-            <a:off x="320040" y="4236720"/>
-            <a:ext cx="402336" cy="1155192"/>
-          </a:xfrm>
-          <a:prstGeom prst="rect">
-            <a:avLst/>
-          </a:prstGeom>
-          <a:noFill/>
-        </p:spPr>
-        <p:txBody>
-          <a:bodyPr wrap="square" anchor="ctr">
-            <a:spAutoFit/>
-          </a:bodyPr>
-          <a:lstStyle/>
-          <a:p>
-            <a:pPr algn="ctr"/>
-            <a:r>
-              <a:rPr sz="1300" b="1" i="0">
-                <a:solidFill>
-                  <a:srgbClr val="FFFFFF"/>
-                </a:solidFill>
-              </a:rPr>
-              <a:t>#2</a:t>
-            </a:r>
-          </a:p>
-        </p:txBody>
-      </p:sp>
-      <p:sp>
-        <p:nvSpPr>
-          <p:cNvPr id="34" name="TextBox 33"/>
-          <p:cNvSpPr txBox="1"/>
-          <p:nvPr/>
-        </p:nvSpPr>
-        <p:spPr>
-          <a:xfrm>
-            <a:off x="813816" y="4309872"/>
-            <a:ext cx="4270248" cy="1008888"/>
-          </a:xfrm>
-          <a:prstGeom prst="rect">
-            <a:avLst/>
-          </a:prstGeom>
-          <a:noFill/>
-        </p:spPr>
-        <p:txBody>
-          <a:bodyPr wrap="square" anchor="t">
-            <a:spAutoFit/>
-          </a:bodyPr>
-          <a:lstStyle/>
-          <a:p>
-            <a:pPr algn="l"/>
-            <a:r>
-              <a:rPr sz="1100" b="0" i="0">
-                <a:solidFill>
-                  <a:srgbClr val="111110"/>
-                </a:solidFill>
-              </a:rPr>
-              <a:t>{{TOP_SKILL_2}}</a:t>
-            </a:r>
-          </a:p>
-        </p:txBody>
-      </p:sp>
-      <p:sp>
-        <p:nvSpPr>
-          <p:cNvPr id="35" name="Rectangle 34"/>
+          <p:cNvPr id="33" name="Rectangle 32"/>
           <p:cNvSpPr/>
           <p:nvPr/>
         </p:nvSpPr>
         <p:spPr>
           <a:xfrm>
-            <a:off x="320040" y="5474208"/>
-            <a:ext cx="4800600" cy="1155192"/>
+            <a:off x="420623" y="4291584"/>
+            <a:ext cx="420624" cy="1072895"/>
           </a:xfrm>
           <a:prstGeom prst="rect">
             <a:avLst/>
           </a:prstGeom>
           <a:solidFill>
-            <a:srgbClr val="CFE7E2"/>
+            <a:srgbClr val="C02026"/>
           </a:solidFill>
           <a:ln>
             <a:noFill/>
           </a:ln>
+          <a:effectLst/>
         </p:spPr>
         <p:style>
           <a:lnRef idx="1">
@@ -5545,24 +5629,97 @@
       </p:sp>
       <p:sp>
         <p:nvSpPr>
+          <p:cNvPr id="34" name="TextBox 33"/>
+          <p:cNvSpPr txBox="1"/>
+          <p:nvPr/>
+        </p:nvSpPr>
+        <p:spPr>
+          <a:xfrm>
+            <a:off x="420623" y="4291584"/>
+            <a:ext cx="420624" cy="1072895"/>
+          </a:xfrm>
+          <a:prstGeom prst="rect">
+            <a:avLst/>
+          </a:prstGeom>
+          <a:noFill/>
+        </p:spPr>
+        <p:txBody>
+          <a:bodyPr wrap="square" anchor="ctr" tIns="0" bIns="0">
+            <a:spAutoFit/>
+          </a:bodyPr>
+          <a:lstStyle/>
+          <a:p>
+            <a:pPr algn="ctr"/>
+            <a:r>
+              <a:rPr sz="1400" b="1" i="0">
+                <a:solidFill>
+                  <a:srgbClr val="FFFFFF"/>
+                </a:solidFill>
+                <a:latin typeface="Calibri"/>
+              </a:rPr>
+              <a:t>#2</a:t>
+            </a:r>
+          </a:p>
+        </p:txBody>
+      </p:sp>
+      <p:sp>
+        <p:nvSpPr>
+          <p:cNvPr id="35" name="TextBox 34"/>
+          <p:cNvSpPr txBox="1"/>
+          <p:nvPr/>
+        </p:nvSpPr>
+        <p:spPr>
+          <a:xfrm>
+            <a:off x="950976" y="4346448"/>
+            <a:ext cx="4197096" cy="963167"/>
+          </a:xfrm>
+          <a:prstGeom prst="rect">
+            <a:avLst/>
+          </a:prstGeom>
+          <a:noFill/>
+        </p:spPr>
+        <p:txBody>
+          <a:bodyPr wrap="square" anchor="ctr" tIns="0" bIns="0">
+            <a:spAutoFit/>
+          </a:bodyPr>
+          <a:lstStyle/>
+          <a:p>
+            <a:pPr algn="l"/>
+            <a:r>
+              <a:rPr sz="1100" b="0" i="0">
+                <a:solidFill>
+                  <a:srgbClr val="3E3E3E"/>
+                </a:solidFill>
+                <a:latin typeface="Calibri"/>
+              </a:rPr>
+              <a:t>{{TOP_SKILL_2}}</a:t>
+            </a:r>
+          </a:p>
+        </p:txBody>
+      </p:sp>
+      <p:sp>
+        <p:nvSpPr>
           <p:cNvPr id="36" name="Rectangle 35"/>
           <p:cNvSpPr/>
           <p:nvPr/>
         </p:nvSpPr>
         <p:spPr>
           <a:xfrm>
-            <a:off x="320040" y="5474208"/>
-            <a:ext cx="402336" cy="1155192"/>
+            <a:off x="420623" y="5455920"/>
+            <a:ext cx="4782312" cy="1072895"/>
           </a:xfrm>
           <a:prstGeom prst="rect">
             <a:avLst/>
           </a:prstGeom>
           <a:solidFill>
-            <a:srgbClr val="2C6E66"/>
+            <a:srgbClr val="F5F5F5"/>
           </a:solidFill>
-          <a:ln>
-            <a:noFill/>
+          <a:ln w="9525">
+            <a:solidFill>
+              <a:srgbClr val="DEDEDE"/>
+            </a:solidFill>
           </a:ln>
+          <a:effectLst/>
         </p:spPr>
         <p:style>
           <a:lnRef idx="1">
@@ -5588,92 +5745,25 @@
       </p:sp>
       <p:sp>
         <p:nvSpPr>
-          <p:cNvPr id="37" name="TextBox 36"/>
-          <p:cNvSpPr txBox="1"/>
-          <p:nvPr/>
-        </p:nvSpPr>
-        <p:spPr>
-          <a:xfrm>
-            <a:off x="320040" y="5474208"/>
-            <a:ext cx="402336" cy="1155192"/>
-          </a:xfrm>
-          <a:prstGeom prst="rect">
-            <a:avLst/>
-          </a:prstGeom>
-          <a:noFill/>
-        </p:spPr>
-        <p:txBody>
-          <a:bodyPr wrap="square" anchor="ctr">
-            <a:spAutoFit/>
-          </a:bodyPr>
-          <a:lstStyle/>
-          <a:p>
-            <a:pPr algn="ctr"/>
-            <a:r>
-              <a:rPr sz="1300" b="1" i="0">
-                <a:solidFill>
-                  <a:srgbClr val="FFFFFF"/>
-                </a:solidFill>
-              </a:rPr>
-              <a:t>#3</a:t>
-            </a:r>
-          </a:p>
-        </p:txBody>
-      </p:sp>
-      <p:sp>
-        <p:nvSpPr>
-          <p:cNvPr id="38" name="TextBox 37"/>
-          <p:cNvSpPr txBox="1"/>
-          <p:nvPr/>
-        </p:nvSpPr>
-        <p:spPr>
-          <a:xfrm>
-            <a:off x="813816" y="5547360"/>
-            <a:ext cx="4270248" cy="1008888"/>
-          </a:xfrm>
-          <a:prstGeom prst="rect">
-            <a:avLst/>
-          </a:prstGeom>
-          <a:noFill/>
-        </p:spPr>
-        <p:txBody>
-          <a:bodyPr wrap="square" anchor="t">
-            <a:spAutoFit/>
-          </a:bodyPr>
-          <a:lstStyle/>
-          <a:p>
-            <a:pPr algn="l"/>
-            <a:r>
-              <a:rPr sz="1100" b="0" i="0">
-                <a:solidFill>
-                  <a:srgbClr val="111110"/>
-                </a:solidFill>
-              </a:rPr>
-              <a:t>{{TOP_SKILL_3}}</a:t>
-            </a:r>
-          </a:p>
-        </p:txBody>
-      </p:sp>
-      <p:sp>
-        <p:nvSpPr>
-          <p:cNvPr id="39" name="Rectangle 38"/>
+          <p:cNvPr id="37" name="Rectangle 36"/>
           <p:cNvSpPr/>
           <p:nvPr/>
         </p:nvSpPr>
         <p:spPr>
           <a:xfrm>
-            <a:off x="5468112" y="2496312"/>
-            <a:ext cx="6537959" cy="4270248"/>
+            <a:off x="420623" y="5455920"/>
+            <a:ext cx="420624" cy="1072895"/>
           </a:xfrm>
           <a:prstGeom prst="rect">
             <a:avLst/>
           </a:prstGeom>
           <a:solidFill>
-            <a:srgbClr val="FFFFFF"/>
+            <a:srgbClr val="C02026"/>
           </a:solidFill>
           <a:ln>
             <a:noFill/>
           </a:ln>
+          <a:effectLst/>
         </p:spPr>
         <p:style>
           <a:lnRef idx="1">
@@ -5699,24 +5789,97 @@
       </p:sp>
       <p:sp>
         <p:nvSpPr>
+          <p:cNvPr id="38" name="TextBox 37"/>
+          <p:cNvSpPr txBox="1"/>
+          <p:nvPr/>
+        </p:nvSpPr>
+        <p:spPr>
+          <a:xfrm>
+            <a:off x="420623" y="5455920"/>
+            <a:ext cx="420624" cy="1072895"/>
+          </a:xfrm>
+          <a:prstGeom prst="rect">
+            <a:avLst/>
+          </a:prstGeom>
+          <a:noFill/>
+        </p:spPr>
+        <p:txBody>
+          <a:bodyPr wrap="square" anchor="ctr" tIns="0" bIns="0">
+            <a:spAutoFit/>
+          </a:bodyPr>
+          <a:lstStyle/>
+          <a:p>
+            <a:pPr algn="ctr"/>
+            <a:r>
+              <a:rPr sz="1400" b="1" i="0">
+                <a:solidFill>
+                  <a:srgbClr val="FFFFFF"/>
+                </a:solidFill>
+                <a:latin typeface="Calibri"/>
+              </a:rPr>
+              <a:t>#3</a:t>
+            </a:r>
+          </a:p>
+        </p:txBody>
+      </p:sp>
+      <p:sp>
+        <p:nvSpPr>
+          <p:cNvPr id="39" name="TextBox 38"/>
+          <p:cNvSpPr txBox="1"/>
+          <p:nvPr/>
+        </p:nvSpPr>
+        <p:spPr>
+          <a:xfrm>
+            <a:off x="950976" y="5510784"/>
+            <a:ext cx="4197096" cy="963167"/>
+          </a:xfrm>
+          <a:prstGeom prst="rect">
+            <a:avLst/>
+          </a:prstGeom>
+          <a:noFill/>
+        </p:spPr>
+        <p:txBody>
+          <a:bodyPr wrap="square" anchor="ctr" tIns="0" bIns="0">
+            <a:spAutoFit/>
+          </a:bodyPr>
+          <a:lstStyle/>
+          <a:p>
+            <a:pPr algn="l"/>
+            <a:r>
+              <a:rPr sz="1100" b="0" i="0">
+                <a:solidFill>
+                  <a:srgbClr val="3E3E3E"/>
+                </a:solidFill>
+                <a:latin typeface="Calibri"/>
+              </a:rPr>
+              <a:t>{{TOP_SKILL_3}}</a:t>
+            </a:r>
+          </a:p>
+        </p:txBody>
+      </p:sp>
+      <p:sp>
+        <p:nvSpPr>
           <p:cNvPr id="40" name="Rectangle 39"/>
           <p:cNvSpPr/>
           <p:nvPr/>
         </p:nvSpPr>
         <p:spPr>
           <a:xfrm>
-            <a:off x="5468112" y="2496312"/>
-            <a:ext cx="6537959" cy="45720"/>
+            <a:off x="5568696" y="2560320"/>
+            <a:ext cx="6345936" cy="4041647"/>
           </a:xfrm>
           <a:prstGeom prst="rect">
             <a:avLst/>
           </a:prstGeom>
           <a:solidFill>
-            <a:srgbClr val="2C6E66"/>
+            <a:srgbClr val="FFFFFF"/>
           </a:solidFill>
-          <a:ln>
-            <a:noFill/>
+          <a:ln w="9525">
+            <a:solidFill>
+              <a:srgbClr val="DEDEDE"/>
+            </a:solidFill>
           </a:ln>
+          <a:effectLst/>
         </p:spPr>
         <p:style>
           <a:lnRef idx="1">
@@ -5742,58 +5905,25 @@
       </p:sp>
       <p:sp>
         <p:nvSpPr>
-          <p:cNvPr id="41" name="TextBox 40"/>
-          <p:cNvSpPr txBox="1"/>
-          <p:nvPr/>
-        </p:nvSpPr>
-        <p:spPr>
-          <a:xfrm>
-            <a:off x="5605272" y="2633472"/>
-            <a:ext cx="6263640" cy="256032"/>
-          </a:xfrm>
-          <a:prstGeom prst="rect">
-            <a:avLst/>
-          </a:prstGeom>
-          <a:noFill/>
-        </p:spPr>
-        <p:txBody>
-          <a:bodyPr wrap="square" anchor="t">
-            <a:spAutoFit/>
-          </a:bodyPr>
-          <a:lstStyle/>
-          <a:p>
-            <a:pPr algn="l"/>
-            <a:r>
-              <a:rPr sz="1100" b="1" i="0">
-                <a:solidFill>
-                  <a:srgbClr val="2C6E66"/>
-                </a:solidFill>
-              </a:rPr>
-              <a:t>FUNCTION DISTRIBUTION</a:t>
-            </a:r>
-          </a:p>
-        </p:txBody>
-      </p:sp>
-      <p:sp>
-        <p:nvSpPr>
-          <p:cNvPr id="42" name="Rectangle 41"/>
+          <p:cNvPr id="41" name="Rectangle 40"/>
           <p:cNvSpPr/>
           <p:nvPr/>
         </p:nvSpPr>
         <p:spPr>
           <a:xfrm>
-            <a:off x="5605272" y="2926079"/>
-            <a:ext cx="6263640" cy="20116"/>
+            <a:off x="5568696" y="2560320"/>
+            <a:ext cx="6345936" cy="54864"/>
           </a:xfrm>
           <a:prstGeom prst="rect">
             <a:avLst/>
           </a:prstGeom>
           <a:solidFill>
-            <a:srgbClr val="7FB2A9"/>
+            <a:srgbClr val="3A8B82"/>
           </a:solidFill>
           <a:ln>
             <a:noFill/>
           </a:ln>
+          <a:effectLst/>
         </p:spPr>
         <p:style>
           <a:lnRef idx="1">
@@ -5819,14 +5949,14 @@
       </p:sp>
       <p:sp>
         <p:nvSpPr>
-          <p:cNvPr id="43" name="TextBox 42"/>
+          <p:cNvPr id="42" name="TextBox 41"/>
           <p:cNvSpPr txBox="1"/>
           <p:nvPr/>
         </p:nvSpPr>
         <p:spPr>
           <a:xfrm>
-            <a:off x="5605272" y="2980944"/>
-            <a:ext cx="6263640" cy="3694175"/>
+            <a:off x="5715000" y="2706624"/>
+            <a:ext cx="6053328" cy="256032"/>
           </a:xfrm>
           <a:prstGeom prst="rect">
             <a:avLst/>
@@ -5834,17 +5964,97 @@
           <a:noFill/>
         </p:spPr>
         <p:txBody>
-          <a:bodyPr wrap="square" anchor="t">
+          <a:bodyPr wrap="square" anchor="t" tIns="0" bIns="0">
             <a:spAutoFit/>
           </a:bodyPr>
           <a:lstStyle/>
           <a:p>
             <a:pPr algn="l"/>
             <a:r>
+              <a:rPr sz="1100" b="1" i="0">
+                <a:solidFill>
+                  <a:srgbClr val="3A8B82"/>
+                </a:solidFill>
+                <a:latin typeface="Calibri"/>
+              </a:rPr>
+              <a:t>FUNCTION DISTRIBUTION</a:t>
+            </a:r>
+          </a:p>
+        </p:txBody>
+      </p:sp>
+      <p:sp>
+        <p:nvSpPr>
+          <p:cNvPr id="43" name="Rectangle 42"/>
+          <p:cNvSpPr/>
+          <p:nvPr/>
+        </p:nvSpPr>
+        <p:spPr>
+          <a:xfrm>
+            <a:off x="5715000" y="2980944"/>
+            <a:ext cx="6053328" cy="20116"/>
+          </a:xfrm>
+          <a:prstGeom prst="rect">
+            <a:avLst/>
+          </a:prstGeom>
+          <a:solidFill>
+            <a:srgbClr val="3A8B82"/>
+          </a:solidFill>
+          <a:ln>
+            <a:noFill/>
+          </a:ln>
+          <a:effectLst/>
+        </p:spPr>
+        <p:style>
+          <a:lnRef idx="1">
+            <a:schemeClr val="accent1"/>
+          </a:lnRef>
+          <a:fillRef idx="3">
+            <a:schemeClr val="accent1"/>
+          </a:fillRef>
+          <a:effectRef idx="2">
+            <a:schemeClr val="accent1"/>
+          </a:effectRef>
+          <a:fontRef idx="minor">
+            <a:schemeClr val="lt1"/>
+          </a:fontRef>
+        </p:style>
+        <p:txBody>
+          <a:bodyPr rtlCol="0" anchor="ctr"/>
+          <a:lstStyle/>
+          <a:p>
+            <a:pPr algn="ctr"/>
+          </a:p>
+        </p:txBody>
+      </p:sp>
+      <p:sp>
+        <p:nvSpPr>
+          <p:cNvPr id="44" name="TextBox 43"/>
+          <p:cNvSpPr txBox="1"/>
+          <p:nvPr/>
+        </p:nvSpPr>
+        <p:spPr>
+          <a:xfrm>
+            <a:off x="5715000" y="3108960"/>
+            <a:ext cx="6053328" cy="3419855"/>
+          </a:xfrm>
+          <a:prstGeom prst="rect">
+            <a:avLst/>
+          </a:prstGeom>
+          <a:noFill/>
+        </p:spPr>
+        <p:txBody>
+          <a:bodyPr wrap="square" anchor="t" tIns="0" bIns="0">
+            <a:spAutoFit/>
+          </a:bodyPr>
+          <a:lstStyle/>
+          <a:p>
+            <a:pPr algn="l"/>
+            <a:r>
               <a:rPr sz="1000" b="0" i="0">
                 <a:solidFill>
-                  <a:srgbClr val="555555"/>
+                  <a:srgbClr val="6E6E69"/>
                 </a:solidFill>
+                <a:latin typeface="Calibri"/>
               </a:rPr>
               <a:t>{{CHART}}</a:t>
             </a:r>
@@ -5878,17 +6088,18 @@
         <p:spPr>
           <a:xfrm>
             <a:off x="0" y="0"/>
-            <a:ext cx="12188952" cy="6858000"/>
+            <a:ext cx="5852160" cy="91440"/>
           </a:xfrm>
           <a:prstGeom prst="rect">
             <a:avLst/>
           </a:prstGeom>
           <a:solidFill>
-            <a:srgbClr val="F0F2F1"/>
+            <a:srgbClr val="C02026"/>
           </a:solidFill>
           <a:ln>
             <a:noFill/>
           </a:ln>
+          <a:effectLst/>
         </p:spPr>
         <p:style>
           <a:lnRef idx="1">
@@ -5920,18 +6131,19 @@
         </p:nvSpPr>
         <p:spPr>
           <a:xfrm>
-            <a:off x="0" y="0"/>
-            <a:ext cx="12188952" cy="960120"/>
+            <a:off x="5852160" y="0"/>
+            <a:ext cx="6336792" cy="91440"/>
           </a:xfrm>
           <a:prstGeom prst="rect">
             <a:avLst/>
           </a:prstGeom>
           <a:solidFill>
-            <a:srgbClr val="2C6E66"/>
+            <a:srgbClr val="3A8B82"/>
           </a:solidFill>
           <a:ln>
             <a:noFill/>
           </a:ln>
+          <a:effectLst/>
         </p:spPr>
         <p:style>
           <a:lnRef idx="1">
@@ -5957,92 +6169,25 @@
       </p:sp>
       <p:sp>
         <p:nvSpPr>
-          <p:cNvPr id="4" name="TextBox 3"/>
-          <p:cNvSpPr txBox="1"/>
-          <p:nvPr/>
-        </p:nvSpPr>
-        <p:spPr>
-          <a:xfrm>
-            <a:off x="274320" y="82296"/>
-            <a:ext cx="11823192" cy="512064"/>
-          </a:xfrm>
-          <a:prstGeom prst="rect">
-            <a:avLst/>
-          </a:prstGeom>
-          <a:noFill/>
-        </p:spPr>
-        <p:txBody>
-          <a:bodyPr wrap="square" anchor="t">
-            <a:spAutoFit/>
-          </a:bodyPr>
-          <a:lstStyle/>
-          <a:p>
-            <a:pPr algn="l"/>
-            <a:r>
-              <a:rPr sz="1700" b="1" i="0">
-                <a:solidFill>
-                  <a:srgbClr val="FFFFFF"/>
-                </a:solidFill>
-              </a:rPr>
-              <a:t>OUR PARTNERSHIP WITH  {{COMPANY_NAME}}  —  DELIVERY OVERVIEW</a:t>
-            </a:r>
-          </a:p>
-        </p:txBody>
-      </p:sp>
-      <p:sp>
-        <p:nvSpPr>
-          <p:cNvPr id="5" name="TextBox 4"/>
-          <p:cNvSpPr txBox="1"/>
-          <p:nvPr/>
-        </p:nvSpPr>
-        <p:spPr>
-          <a:xfrm>
-            <a:off x="274320" y="612648"/>
-            <a:ext cx="11823192" cy="292608"/>
-          </a:xfrm>
-          <a:prstGeom prst="rect">
-            <a:avLst/>
-          </a:prstGeom>
-          <a:noFill/>
-        </p:spPr>
-        <p:txBody>
-          <a:bodyPr wrap="square" anchor="t">
-            <a:spAutoFit/>
-          </a:bodyPr>
-          <a:lstStyle/>
-          <a:p>
-            <a:pPr algn="l"/>
-            <a:r>
-              <a:rPr sz="900" b="0" i="1">
-                <a:solidFill>
-                  <a:srgbClr val="CFE7E2"/>
-                </a:solidFill>
-              </a:rPr>
-              <a:t>Our existing J2W relationship — people, skills &amp; engagement</a:t>
-            </a:r>
-          </a:p>
-        </p:txBody>
-      </p:sp>
-      <p:sp>
-        <p:nvSpPr>
-          <p:cNvPr id="6" name="Rectangle 5"/>
+          <p:cNvPr id="4" name="Rectangle 3"/>
           <p:cNvSpPr/>
           <p:nvPr/>
         </p:nvSpPr>
         <p:spPr>
           <a:xfrm>
-            <a:off x="182880" y="1051560"/>
-            <a:ext cx="2859786" cy="1280160"/>
+            <a:off x="228600" y="274320"/>
+            <a:ext cx="59436" cy="475488"/>
           </a:xfrm>
           <a:prstGeom prst="rect">
             <a:avLst/>
           </a:prstGeom>
           <a:solidFill>
-            <a:srgbClr val="FFFFFF"/>
+            <a:srgbClr val="C02026"/>
           </a:solidFill>
           <a:ln>
             <a:noFill/>
           </a:ln>
+          <a:effectLst/>
         </p:spPr>
         <p:style>
           <a:lnRef idx="1">
@@ -6068,24 +6213,95 @@
       </p:sp>
       <p:sp>
         <p:nvSpPr>
+          <p:cNvPr id="5" name="TextBox 4"/>
+          <p:cNvSpPr txBox="1"/>
+          <p:nvPr/>
+        </p:nvSpPr>
+        <p:spPr>
+          <a:xfrm>
+            <a:off x="402336" y="237744"/>
+            <a:ext cx="11338560" cy="475488"/>
+          </a:xfrm>
+          <a:prstGeom prst="rect">
+            <a:avLst/>
+          </a:prstGeom>
+          <a:noFill/>
+        </p:spPr>
+        <p:txBody>
+          <a:bodyPr wrap="square" anchor="t" tIns="0" bIns="0">
+            <a:spAutoFit/>
+          </a:bodyPr>
+          <a:lstStyle/>
+          <a:p>
+            <a:pPr algn="l"/>
+            <a:r>
+              <a:rPr sz="2400" b="1" i="0">
+                <a:solidFill>
+                  <a:srgbClr val="111110"/>
+                </a:solidFill>
+                <a:latin typeface="Calibri"/>
+              </a:rPr>
+              <a:t>OUR PARTNERSHIP OVERVIEW</a:t>
+            </a:r>
+          </a:p>
+        </p:txBody>
+      </p:sp>
+      <p:sp>
+        <p:nvSpPr>
+          <p:cNvPr id="6" name="TextBox 5"/>
+          <p:cNvSpPr txBox="1"/>
+          <p:nvPr/>
+        </p:nvSpPr>
+        <p:spPr>
+          <a:xfrm>
+            <a:off x="402336" y="731520"/>
+            <a:ext cx="11521440" cy="310896"/>
+          </a:xfrm>
+          <a:prstGeom prst="rect">
+            <a:avLst/>
+          </a:prstGeom>
+          <a:noFill/>
+        </p:spPr>
+        <p:txBody>
+          <a:bodyPr wrap="square" anchor="t" tIns="0" bIns="0">
+            <a:spAutoFit/>
+          </a:bodyPr>
+          <a:lstStyle/>
+          <a:p>
+            <a:pPr algn="l"/>
+            <a:r>
+              <a:rPr sz="1400" b="1" i="0">
+                <a:solidFill>
+                  <a:srgbClr val="3A8B82"/>
+                </a:solidFill>
+                <a:latin typeface="Calibri"/>
+              </a:rPr>
+              <a:t>CLIENT:  {{COMPANY_NAME}}   |   EXISTING J2W RELATIONSHIP</a:t>
+            </a:r>
+          </a:p>
+        </p:txBody>
+      </p:sp>
+      <p:sp>
+        <p:nvSpPr>
           <p:cNvPr id="7" name="Rectangle 6"/>
           <p:cNvSpPr/>
           <p:nvPr/>
         </p:nvSpPr>
         <p:spPr>
           <a:xfrm>
-            <a:off x="182880" y="1051560"/>
-            <a:ext cx="2859786" cy="45720"/>
+            <a:off x="0" y="6766560"/>
+            <a:ext cx="12188952" cy="91440"/>
           </a:xfrm>
           <a:prstGeom prst="rect">
             <a:avLst/>
           </a:prstGeom>
           <a:solidFill>
-            <a:srgbClr val="2C6E66"/>
+            <a:srgbClr val="3A8B82"/>
           </a:solidFill>
           <a:ln>
             <a:noFill/>
           </a:ln>
+          <a:effectLst/>
         </p:spPr>
         <p:style>
           <a:lnRef idx="1">
@@ -6111,82 +6327,14 @@
       </p:sp>
       <p:sp>
         <p:nvSpPr>
-          <p:cNvPr id="8" name="TextBox 7"/>
-          <p:cNvSpPr txBox="1"/>
-          <p:nvPr/>
-        </p:nvSpPr>
-        <p:spPr>
-          <a:xfrm>
-            <a:off x="320040" y="1143000"/>
-            <a:ext cx="2585466" cy="621792"/>
-          </a:xfrm>
-          <a:prstGeom prst="rect">
-            <a:avLst/>
-          </a:prstGeom>
-          <a:noFill/>
-        </p:spPr>
-        <p:txBody>
-          <a:bodyPr wrap="square" anchor="t">
-            <a:spAutoFit/>
-          </a:bodyPr>
-          <a:lstStyle/>
-          <a:p>
-            <a:pPr algn="ctr"/>
-            <a:r>
-              <a:rPr sz="2600" b="1" i="0">
-                <a:solidFill>
-                  <a:srgbClr val="2C6E66"/>
-                </a:solidFill>
-              </a:rPr>
-              <a:t>{{TOTAL_DEPLOYED}}</a:t>
-            </a:r>
-          </a:p>
-        </p:txBody>
-      </p:sp>
-      <p:sp>
-        <p:nvSpPr>
-          <p:cNvPr id="9" name="TextBox 8"/>
-          <p:cNvSpPr txBox="1"/>
-          <p:nvPr/>
-        </p:nvSpPr>
-        <p:spPr>
-          <a:xfrm>
-            <a:off x="320040" y="1783080"/>
-            <a:ext cx="2585466" cy="475488"/>
-          </a:xfrm>
-          <a:prstGeom prst="rect">
-            <a:avLst/>
-          </a:prstGeom>
-          <a:noFill/>
-        </p:spPr>
-        <p:txBody>
-          <a:bodyPr wrap="square" anchor="t">
-            <a:spAutoFit/>
-          </a:bodyPr>
-          <a:lstStyle/>
-          <a:p>
-            <a:pPr algn="ctr"/>
-            <a:r>
-              <a:rPr sz="900" b="0" i="0">
-                <a:solidFill>
-                  <a:srgbClr val="555555"/>
-                </a:solidFill>
-              </a:rPr>
-              <a:t>Consultants deployed</a:t>
-            </a:r>
-          </a:p>
-        </p:txBody>
-      </p:sp>
-      <p:sp>
-        <p:nvSpPr>
-          <p:cNvPr id="10" name="Rectangle 9"/>
+          <p:cNvPr id="8" name="Rectangle 7"/>
           <p:cNvSpPr/>
           <p:nvPr/>
         </p:nvSpPr>
         <p:spPr>
           <a:xfrm>
-            <a:off x="3170682" y="1051560"/>
-            <a:ext cx="2859786" cy="1280160"/>
+            <a:off x="274320" y="1188720"/>
+            <a:ext cx="2786634" cy="1170432"/>
           </a:xfrm>
           <a:prstGeom prst="rect">
             <a:avLst/>
@@ -6194,9 +6342,12 @@
           <a:solidFill>
             <a:srgbClr val="FFFFFF"/>
           </a:solidFill>
-          <a:ln>
-            <a:noFill/>
+          <a:ln w="9525">
+            <a:solidFill>
+              <a:srgbClr val="DEDEDE"/>
+            </a:solidFill>
           </a:ln>
+          <a:effectLst/>
         </p:spPr>
         <p:style>
           <a:lnRef idx="1">
@@ -6222,24 +6373,25 @@
       </p:sp>
       <p:sp>
         <p:nvSpPr>
-          <p:cNvPr id="11" name="Rectangle 10"/>
+          <p:cNvPr id="9" name="Rectangle 8"/>
           <p:cNvSpPr/>
           <p:nvPr/>
         </p:nvSpPr>
         <p:spPr>
           <a:xfrm>
-            <a:off x="3170682" y="1051560"/>
-            <a:ext cx="2859786" cy="45720"/>
+            <a:off x="274320" y="1188720"/>
+            <a:ext cx="2786634" cy="45720"/>
           </a:xfrm>
           <a:prstGeom prst="rect">
             <a:avLst/>
           </a:prstGeom>
           <a:solidFill>
-            <a:srgbClr val="2C6E66"/>
+            <a:srgbClr val="3A8B82"/>
           </a:solidFill>
           <a:ln>
             <a:noFill/>
           </a:ln>
+          <a:effectLst/>
         </p:spPr>
         <p:style>
           <a:lnRef idx="1">
@@ -6265,14 +6417,14 @@
       </p:sp>
       <p:sp>
         <p:nvSpPr>
-          <p:cNvPr id="12" name="TextBox 11"/>
+          <p:cNvPr id="10" name="TextBox 9"/>
           <p:cNvSpPr txBox="1"/>
           <p:nvPr/>
         </p:nvSpPr>
         <p:spPr>
           <a:xfrm>
-            <a:off x="3307842" y="1143000"/>
-            <a:ext cx="2585466" cy="621792"/>
+            <a:off x="347472" y="1371600"/>
+            <a:ext cx="2640330" cy="603504"/>
           </a:xfrm>
           <a:prstGeom prst="rect">
             <a:avLst/>
@@ -6280,33 +6432,34 @@
           <a:noFill/>
         </p:spPr>
         <p:txBody>
-          <a:bodyPr wrap="square" anchor="t">
+          <a:bodyPr wrap="square" anchor="t" tIns="0" bIns="0">
             <a:spAutoFit/>
           </a:bodyPr>
           <a:lstStyle/>
           <a:p>
             <a:pPr algn="ctr"/>
             <a:r>
-              <a:rPr sz="2600" b="1" i="0">
+              <a:rPr sz="2700" b="1" i="0">
                 <a:solidFill>
-                  <a:srgbClr val="2C6E66"/>
+                  <a:srgbClr val="3A8B82"/>
                 </a:solidFill>
+                <a:latin typeface="Calibri"/>
               </a:rPr>
-              <a:t>{{NUM_FUNCTIONS_CO}}</a:t>
-            </a:r>
-          </a:p>
-        </p:txBody>
-      </p:sp>
-      <p:sp>
-        <p:nvSpPr>
-          <p:cNvPr id="13" name="TextBox 12"/>
+              <a:t>{{TOTAL_DEPLOYED}}</a:t>
+            </a:r>
+          </a:p>
+        </p:txBody>
+      </p:sp>
+      <p:sp>
+        <p:nvSpPr>
+          <p:cNvPr id="11" name="TextBox 10"/>
           <p:cNvSpPr txBox="1"/>
           <p:nvPr/>
         </p:nvSpPr>
         <p:spPr>
           <a:xfrm>
-            <a:off x="3307842" y="1783080"/>
-            <a:ext cx="2585466" cy="475488"/>
+            <a:off x="347472" y="2011680"/>
+            <a:ext cx="2640330" cy="292608"/>
           </a:xfrm>
           <a:prstGeom prst="rect">
             <a:avLst/>
@@ -6314,7 +6467,7 @@
           <a:noFill/>
         </p:spPr>
         <p:txBody>
-          <a:bodyPr wrap="square" anchor="t">
+          <a:bodyPr wrap="square" anchor="t" tIns="0" bIns="0">
             <a:spAutoFit/>
           </a:bodyPr>
           <a:lstStyle/>
@@ -6323,24 +6476,25 @@
             <a:r>
               <a:rPr sz="900" b="0" i="0">
                 <a:solidFill>
-                  <a:srgbClr val="555555"/>
+                  <a:srgbClr val="6E6E69"/>
                 </a:solidFill>
+                <a:latin typeface="Calibri"/>
               </a:rPr>
-              <a:t>Functions delivered</a:t>
-            </a:r>
-          </a:p>
-        </p:txBody>
-      </p:sp>
-      <p:sp>
-        <p:nvSpPr>
-          <p:cNvPr id="14" name="Rectangle 13"/>
+              <a:t>Consultants deployed</a:t>
+            </a:r>
+          </a:p>
+        </p:txBody>
+      </p:sp>
+      <p:sp>
+        <p:nvSpPr>
+          <p:cNvPr id="12" name="Rectangle 11"/>
           <p:cNvSpPr/>
           <p:nvPr/>
         </p:nvSpPr>
         <p:spPr>
           <a:xfrm>
-            <a:off x="6158484" y="1051560"/>
-            <a:ext cx="2859786" cy="1280160"/>
+            <a:off x="3225546" y="1188720"/>
+            <a:ext cx="2786634" cy="1170432"/>
           </a:xfrm>
           <a:prstGeom prst="rect">
             <a:avLst/>
@@ -6348,9 +6502,12 @@
           <a:solidFill>
             <a:srgbClr val="FFFFFF"/>
           </a:solidFill>
-          <a:ln>
-            <a:noFill/>
+          <a:ln w="9525">
+            <a:solidFill>
+              <a:srgbClr val="DEDEDE"/>
+            </a:solidFill>
           </a:ln>
+          <a:effectLst/>
         </p:spPr>
         <p:style>
           <a:lnRef idx="1">
@@ -6376,24 +6533,25 @@
       </p:sp>
       <p:sp>
         <p:nvSpPr>
-          <p:cNvPr id="15" name="Rectangle 14"/>
+          <p:cNvPr id="13" name="Rectangle 12"/>
           <p:cNvSpPr/>
           <p:nvPr/>
         </p:nvSpPr>
         <p:spPr>
           <a:xfrm>
-            <a:off x="6158484" y="1051560"/>
-            <a:ext cx="2859786" cy="45720"/>
+            <a:off x="3225546" y="1188720"/>
+            <a:ext cx="2786634" cy="45720"/>
           </a:xfrm>
           <a:prstGeom prst="rect">
             <a:avLst/>
           </a:prstGeom>
           <a:solidFill>
-            <a:srgbClr val="2C6E66"/>
+            <a:srgbClr val="3A8B82"/>
           </a:solidFill>
           <a:ln>
             <a:noFill/>
           </a:ln>
+          <a:effectLst/>
         </p:spPr>
         <p:style>
           <a:lnRef idx="1">
@@ -6419,14 +6577,14 @@
       </p:sp>
       <p:sp>
         <p:nvSpPr>
-          <p:cNvPr id="16" name="TextBox 15"/>
+          <p:cNvPr id="14" name="TextBox 13"/>
           <p:cNvSpPr txBox="1"/>
           <p:nvPr/>
         </p:nvSpPr>
         <p:spPr>
           <a:xfrm>
-            <a:off x="6295644" y="1143000"/>
-            <a:ext cx="2585466" cy="621792"/>
+            <a:off x="3298698" y="1371600"/>
+            <a:ext cx="2640330" cy="603504"/>
           </a:xfrm>
           <a:prstGeom prst="rect">
             <a:avLst/>
@@ -6434,33 +6592,34 @@
           <a:noFill/>
         </p:spPr>
         <p:txBody>
-          <a:bodyPr wrap="square" anchor="t">
+          <a:bodyPr wrap="square" anchor="t" tIns="0" bIns="0">
             <a:spAutoFit/>
           </a:bodyPr>
           <a:lstStyle/>
           <a:p>
             <a:pPr algn="ctr"/>
             <a:r>
-              <a:rPr sz="2600" b="1" i="0">
+              <a:rPr sz="2700" b="1" i="0">
                 <a:solidFill>
-                  <a:srgbClr val="2C6E66"/>
+                  <a:srgbClr val="3A8B82"/>
                 </a:solidFill>
+                <a:latin typeface="Calibri"/>
               </a:rPr>
-              <a:t>{{NUM_SKILLS_CO}}</a:t>
-            </a:r>
-          </a:p>
-        </p:txBody>
-      </p:sp>
-      <p:sp>
-        <p:nvSpPr>
-          <p:cNvPr id="17" name="TextBox 16"/>
+              <a:t>{{NUM_FUNCTIONS_CO}}</a:t>
+            </a:r>
+          </a:p>
+        </p:txBody>
+      </p:sp>
+      <p:sp>
+        <p:nvSpPr>
+          <p:cNvPr id="15" name="TextBox 14"/>
           <p:cNvSpPr txBox="1"/>
           <p:nvPr/>
         </p:nvSpPr>
         <p:spPr>
           <a:xfrm>
-            <a:off x="6295644" y="1783080"/>
-            <a:ext cx="2585466" cy="475488"/>
+            <a:off x="3298698" y="2011680"/>
+            <a:ext cx="2640330" cy="292608"/>
           </a:xfrm>
           <a:prstGeom prst="rect">
             <a:avLst/>
@@ -6468,7 +6627,7 @@
           <a:noFill/>
         </p:spPr>
         <p:txBody>
-          <a:bodyPr wrap="square" anchor="t">
+          <a:bodyPr wrap="square" anchor="t" tIns="0" bIns="0">
             <a:spAutoFit/>
           </a:bodyPr>
           <a:lstStyle/>
@@ -6477,24 +6636,25 @@
             <a:r>
               <a:rPr sz="900" b="0" i="0">
                 <a:solidFill>
-                  <a:srgbClr val="555555"/>
+                  <a:srgbClr val="6E6E69"/>
                 </a:solidFill>
+                <a:latin typeface="Calibri"/>
               </a:rPr>
-              <a:t>Distinct skills</a:t>
-            </a:r>
-          </a:p>
-        </p:txBody>
-      </p:sp>
-      <p:sp>
-        <p:nvSpPr>
-          <p:cNvPr id="18" name="Rectangle 17"/>
+              <a:t>Functions delivered</a:t>
+            </a:r>
+          </a:p>
+        </p:txBody>
+      </p:sp>
+      <p:sp>
+        <p:nvSpPr>
+          <p:cNvPr id="16" name="Rectangle 15"/>
           <p:cNvSpPr/>
           <p:nvPr/>
         </p:nvSpPr>
         <p:spPr>
           <a:xfrm>
-            <a:off x="9146286" y="1051560"/>
-            <a:ext cx="2859786" cy="1280160"/>
+            <a:off x="6176772" y="1188720"/>
+            <a:ext cx="2786634" cy="1170432"/>
           </a:xfrm>
           <a:prstGeom prst="rect">
             <a:avLst/>
@@ -6502,9 +6662,12 @@
           <a:solidFill>
             <a:srgbClr val="FFFFFF"/>
           </a:solidFill>
-          <a:ln>
-            <a:noFill/>
+          <a:ln w="9525">
+            <a:solidFill>
+              <a:srgbClr val="DEDEDE"/>
+            </a:solidFill>
           </a:ln>
+          <a:effectLst/>
         </p:spPr>
         <p:style>
           <a:lnRef idx="1">
@@ -6530,24 +6693,25 @@
       </p:sp>
       <p:sp>
         <p:nvSpPr>
-          <p:cNvPr id="19" name="Rectangle 18"/>
+          <p:cNvPr id="17" name="Rectangle 16"/>
           <p:cNvSpPr/>
           <p:nvPr/>
         </p:nvSpPr>
         <p:spPr>
           <a:xfrm>
-            <a:off x="9146286" y="1051560"/>
-            <a:ext cx="2859786" cy="45720"/>
+            <a:off x="6176772" y="1188720"/>
+            <a:ext cx="2786634" cy="45720"/>
           </a:xfrm>
           <a:prstGeom prst="rect">
             <a:avLst/>
           </a:prstGeom>
           <a:solidFill>
-            <a:srgbClr val="2C6E66"/>
+            <a:srgbClr val="3A8B82"/>
           </a:solidFill>
           <a:ln>
             <a:noFill/>
           </a:ln>
+          <a:effectLst/>
         </p:spPr>
         <p:style>
           <a:lnRef idx="1">
@@ -6573,14 +6737,14 @@
       </p:sp>
       <p:sp>
         <p:nvSpPr>
-          <p:cNvPr id="20" name="TextBox 19"/>
+          <p:cNvPr id="18" name="TextBox 17"/>
           <p:cNvSpPr txBox="1"/>
           <p:nvPr/>
         </p:nvSpPr>
         <p:spPr>
           <a:xfrm>
-            <a:off x="9283446" y="1143000"/>
-            <a:ext cx="2585466" cy="621792"/>
+            <a:off x="6249924" y="1371600"/>
+            <a:ext cx="2640330" cy="603504"/>
           </a:xfrm>
           <a:prstGeom prst="rect">
             <a:avLst/>
@@ -6588,33 +6752,34 @@
           <a:noFill/>
         </p:spPr>
         <p:txBody>
-          <a:bodyPr wrap="square" anchor="t">
+          <a:bodyPr wrap="square" anchor="t" tIns="0" bIns="0">
             <a:spAutoFit/>
           </a:bodyPr>
           <a:lstStyle/>
           <a:p>
             <a:pPr algn="ctr"/>
             <a:r>
-              <a:rPr sz="2600" b="1" i="0">
+              <a:rPr sz="2700" b="1" i="0">
                 <a:solidFill>
-                  <a:srgbClr val="2C6E66"/>
+                  <a:srgbClr val="3A8B82"/>
                 </a:solidFill>
+                <a:latin typeface="Calibri"/>
               </a:rPr>
-              <a:t>{{ENGAGEMENT_TYPE}}</a:t>
-            </a:r>
-          </a:p>
-        </p:txBody>
-      </p:sp>
-      <p:sp>
-        <p:nvSpPr>
-          <p:cNvPr id="21" name="TextBox 20"/>
+              <a:t>{{NUM_SKILLS_CO}}</a:t>
+            </a:r>
+          </a:p>
+        </p:txBody>
+      </p:sp>
+      <p:sp>
+        <p:nvSpPr>
+          <p:cNvPr id="19" name="TextBox 18"/>
           <p:cNvSpPr txBox="1"/>
           <p:nvPr/>
         </p:nvSpPr>
         <p:spPr>
           <a:xfrm>
-            <a:off x="9283446" y="1783080"/>
-            <a:ext cx="2585466" cy="475488"/>
+            <a:off x="6249924" y="2011680"/>
+            <a:ext cx="2640330" cy="292608"/>
           </a:xfrm>
           <a:prstGeom prst="rect">
             <a:avLst/>
@@ -6622,7 +6787,7 @@
           <a:noFill/>
         </p:spPr>
         <p:txBody>
-          <a:bodyPr wrap="square" anchor="t">
+          <a:bodyPr wrap="square" anchor="t" tIns="0" bIns="0">
             <a:spAutoFit/>
           </a:bodyPr>
           <a:lstStyle/>
@@ -6631,34 +6796,38 @@
             <a:r>
               <a:rPr sz="900" b="0" i="0">
                 <a:solidFill>
-                  <a:srgbClr val="555555"/>
+                  <a:srgbClr val="6E6E69"/>
                 </a:solidFill>
+                <a:latin typeface="Calibri"/>
               </a:rPr>
-              <a:t>Engagement type</a:t>
-            </a:r>
-          </a:p>
-        </p:txBody>
-      </p:sp>
-      <p:sp>
-        <p:nvSpPr>
-          <p:cNvPr id="22" name="Rectangle 21"/>
+              <a:t>Distinct skills</a:t>
+            </a:r>
+          </a:p>
+        </p:txBody>
+      </p:sp>
+      <p:sp>
+        <p:nvSpPr>
+          <p:cNvPr id="20" name="Rectangle 19"/>
           <p:cNvSpPr/>
           <p:nvPr/>
         </p:nvSpPr>
         <p:spPr>
           <a:xfrm>
-            <a:off x="182880" y="2404872"/>
-            <a:ext cx="11823192" cy="20116"/>
+            <a:off x="9127998" y="1188720"/>
+            <a:ext cx="2786634" cy="1170432"/>
           </a:xfrm>
           <a:prstGeom prst="rect">
             <a:avLst/>
           </a:prstGeom>
           <a:solidFill>
-            <a:srgbClr val="7FB2A9"/>
+            <a:srgbClr val="FFFFFF"/>
           </a:solidFill>
-          <a:ln>
-            <a:noFill/>
+          <a:ln w="9525">
+            <a:solidFill>
+              <a:srgbClr val="DEDEDE"/>
+            </a:solidFill>
           </a:ln>
+          <a:effectLst/>
         </p:spPr>
         <p:style>
           <a:lnRef idx="1">
@@ -6684,24 +6853,25 @@
       </p:sp>
       <p:sp>
         <p:nvSpPr>
-          <p:cNvPr id="23" name="Rectangle 22"/>
+          <p:cNvPr id="21" name="Rectangle 20"/>
           <p:cNvSpPr/>
           <p:nvPr/>
         </p:nvSpPr>
         <p:spPr>
           <a:xfrm>
-            <a:off x="182880" y="2496312"/>
-            <a:ext cx="5074920" cy="4270248"/>
+            <a:off x="9127998" y="1188720"/>
+            <a:ext cx="2786634" cy="45720"/>
           </a:xfrm>
           <a:prstGeom prst="rect">
             <a:avLst/>
           </a:prstGeom>
           <a:solidFill>
-            <a:srgbClr val="FFFFFF"/>
+            <a:srgbClr val="3A8B82"/>
           </a:solidFill>
           <a:ln>
             <a:noFill/>
           </a:ln>
+          <a:effectLst/>
         </p:spPr>
         <p:style>
           <a:lnRef idx="1">
@@ -6727,24 +6897,97 @@
       </p:sp>
       <p:sp>
         <p:nvSpPr>
+          <p:cNvPr id="22" name="TextBox 21"/>
+          <p:cNvSpPr txBox="1"/>
+          <p:nvPr/>
+        </p:nvSpPr>
+        <p:spPr>
+          <a:xfrm>
+            <a:off x="9201150" y="1371600"/>
+            <a:ext cx="2640330" cy="603504"/>
+          </a:xfrm>
+          <a:prstGeom prst="rect">
+            <a:avLst/>
+          </a:prstGeom>
+          <a:noFill/>
+        </p:spPr>
+        <p:txBody>
+          <a:bodyPr wrap="square" anchor="t" tIns="0" bIns="0">
+            <a:spAutoFit/>
+          </a:bodyPr>
+          <a:lstStyle/>
+          <a:p>
+            <a:pPr algn="ctr"/>
+            <a:r>
+              <a:rPr sz="2700" b="1" i="0">
+                <a:solidFill>
+                  <a:srgbClr val="3A8B82"/>
+                </a:solidFill>
+                <a:latin typeface="Calibri"/>
+              </a:rPr>
+              <a:t>{{ENGAGEMENT_TYPE}}</a:t>
+            </a:r>
+          </a:p>
+        </p:txBody>
+      </p:sp>
+      <p:sp>
+        <p:nvSpPr>
+          <p:cNvPr id="23" name="TextBox 22"/>
+          <p:cNvSpPr txBox="1"/>
+          <p:nvPr/>
+        </p:nvSpPr>
+        <p:spPr>
+          <a:xfrm>
+            <a:off x="9201150" y="2011680"/>
+            <a:ext cx="2640330" cy="292608"/>
+          </a:xfrm>
+          <a:prstGeom prst="rect">
+            <a:avLst/>
+          </a:prstGeom>
+          <a:noFill/>
+        </p:spPr>
+        <p:txBody>
+          <a:bodyPr wrap="square" anchor="t" tIns="0" bIns="0">
+            <a:spAutoFit/>
+          </a:bodyPr>
+          <a:lstStyle/>
+          <a:p>
+            <a:pPr algn="ctr"/>
+            <a:r>
+              <a:rPr sz="900" b="0" i="0">
+                <a:solidFill>
+                  <a:srgbClr val="6E6E69"/>
+                </a:solidFill>
+                <a:latin typeface="Calibri"/>
+              </a:rPr>
+              <a:t>Engagement type</a:t>
+            </a:r>
+          </a:p>
+        </p:txBody>
+      </p:sp>
+      <p:sp>
+        <p:nvSpPr>
           <p:cNvPr id="24" name="Rectangle 23"/>
           <p:cNvSpPr/>
           <p:nvPr/>
         </p:nvSpPr>
         <p:spPr>
           <a:xfrm>
-            <a:off x="182880" y="2496312"/>
-            <a:ext cx="45720" cy="4270248"/>
+            <a:off x="274320" y="2560320"/>
+            <a:ext cx="5074920" cy="4041647"/>
           </a:xfrm>
           <a:prstGeom prst="rect">
             <a:avLst/>
           </a:prstGeom>
           <a:solidFill>
-            <a:srgbClr val="2C6E66"/>
+            <a:srgbClr val="FFFFFF"/>
           </a:solidFill>
-          <a:ln>
-            <a:noFill/>
+          <a:ln w="9525">
+            <a:solidFill>
+              <a:srgbClr val="DEDEDE"/>
+            </a:solidFill>
           </a:ln>
+          <a:effectLst/>
         </p:spPr>
         <p:style>
           <a:lnRef idx="1">
@@ -6770,58 +7013,25 @@
       </p:sp>
       <p:sp>
         <p:nvSpPr>
-          <p:cNvPr id="25" name="TextBox 24"/>
-          <p:cNvSpPr txBox="1"/>
-          <p:nvPr/>
-        </p:nvSpPr>
-        <p:spPr>
-          <a:xfrm>
-            <a:off x="320040" y="2633472"/>
-            <a:ext cx="4800600" cy="256032"/>
-          </a:xfrm>
-          <a:prstGeom prst="rect">
-            <a:avLst/>
-          </a:prstGeom>
-          <a:noFill/>
-        </p:spPr>
-        <p:txBody>
-          <a:bodyPr wrap="square" anchor="t">
-            <a:spAutoFit/>
-          </a:bodyPr>
-          <a:lstStyle/>
-          <a:p>
-            <a:pPr algn="l"/>
-            <a:r>
-              <a:rPr sz="1100" b="1" i="0">
-                <a:solidFill>
-                  <a:srgbClr val="2C6E66"/>
-                </a:solidFill>
-              </a:rPr>
-              <a:t>FUNCTION BREAKDOWN</a:t>
-            </a:r>
-          </a:p>
-        </p:txBody>
-      </p:sp>
-      <p:sp>
-        <p:nvSpPr>
-          <p:cNvPr id="26" name="Rectangle 25"/>
+          <p:cNvPr id="25" name="Rectangle 24"/>
           <p:cNvSpPr/>
           <p:nvPr/>
         </p:nvSpPr>
         <p:spPr>
           <a:xfrm>
-            <a:off x="320040" y="2926079"/>
-            <a:ext cx="4800600" cy="20116"/>
+            <a:off x="274320" y="2560320"/>
+            <a:ext cx="54864" cy="4041647"/>
           </a:xfrm>
           <a:prstGeom prst="rect">
             <a:avLst/>
           </a:prstGeom>
           <a:solidFill>
-            <a:srgbClr val="7FB2A9"/>
+            <a:srgbClr val="C02026"/>
           </a:solidFill>
           <a:ln>
             <a:noFill/>
           </a:ln>
+          <a:effectLst/>
         </p:spPr>
         <p:style>
           <a:lnRef idx="1">
@@ -6847,14 +7057,14 @@
       </p:sp>
       <p:sp>
         <p:nvSpPr>
-          <p:cNvPr id="27" name="TextBox 26"/>
+          <p:cNvPr id="26" name="TextBox 25"/>
           <p:cNvSpPr txBox="1"/>
           <p:nvPr/>
         </p:nvSpPr>
         <p:spPr>
           <a:xfrm>
-            <a:off x="320040" y="2980944"/>
-            <a:ext cx="4846320" cy="3694175"/>
+            <a:off x="420623" y="2706624"/>
+            <a:ext cx="4782312" cy="256032"/>
           </a:xfrm>
           <a:prstGeom prst="rect">
             <a:avLst/>
@@ -6862,43 +7072,45 @@
           <a:noFill/>
         </p:spPr>
         <p:txBody>
-          <a:bodyPr wrap="square" anchor="t">
+          <a:bodyPr wrap="square" anchor="t" tIns="0" bIns="0">
             <a:spAutoFit/>
           </a:bodyPr>
           <a:lstStyle/>
           <a:p>
             <a:pPr algn="l"/>
             <a:r>
-              <a:rPr sz="1000" b="0" i="0">
+              <a:rPr sz="1100" b="1" i="0">
                 <a:solidFill>
-                  <a:srgbClr val="111110"/>
+                  <a:srgbClr val="3A8B82"/>
                 </a:solidFill>
+                <a:latin typeface="Calibri"/>
               </a:rPr>
-              <a:t>{{FUNCTION_BREAKDOWN}}</a:t>
-            </a:r>
-          </a:p>
-        </p:txBody>
-      </p:sp>
-      <p:sp>
-        <p:nvSpPr>
-          <p:cNvPr id="28" name="Rectangle 27"/>
+              <a:t>FUNCTION BREAKDOWN</a:t>
+            </a:r>
+          </a:p>
+        </p:txBody>
+      </p:sp>
+      <p:sp>
+        <p:nvSpPr>
+          <p:cNvPr id="27" name="Rectangle 26"/>
           <p:cNvSpPr/>
           <p:nvPr/>
         </p:nvSpPr>
         <p:spPr>
           <a:xfrm>
-            <a:off x="5468112" y="2496312"/>
-            <a:ext cx="6537959" cy="4270248"/>
+            <a:off x="420623" y="2980944"/>
+            <a:ext cx="4782312" cy="20116"/>
           </a:xfrm>
           <a:prstGeom prst="rect">
             <a:avLst/>
           </a:prstGeom>
           <a:solidFill>
-            <a:srgbClr val="FFFFFF"/>
+            <a:srgbClr val="3A8B82"/>
           </a:solidFill>
           <a:ln>
             <a:noFill/>
           </a:ln>
+          <a:effectLst/>
         </p:spPr>
         <p:style>
           <a:lnRef idx="1">
@@ -6924,24 +7136,62 @@
       </p:sp>
       <p:sp>
         <p:nvSpPr>
+          <p:cNvPr id="28" name="TextBox 27"/>
+          <p:cNvSpPr txBox="1"/>
+          <p:nvPr/>
+        </p:nvSpPr>
+        <p:spPr>
+          <a:xfrm>
+            <a:off x="420623" y="3108960"/>
+            <a:ext cx="4782312" cy="3419855"/>
+          </a:xfrm>
+          <a:prstGeom prst="rect">
+            <a:avLst/>
+          </a:prstGeom>
+          <a:noFill/>
+        </p:spPr>
+        <p:txBody>
+          <a:bodyPr wrap="square" anchor="t" tIns="0" bIns="0">
+            <a:spAutoFit/>
+          </a:bodyPr>
+          <a:lstStyle/>
+          <a:p>
+            <a:pPr algn="l"/>
+            <a:r>
+              <a:rPr sz="1000" b="0" i="0">
+                <a:solidFill>
+                  <a:srgbClr val="3E3E3E"/>
+                </a:solidFill>
+                <a:latin typeface="Calibri"/>
+              </a:rPr>
+              <a:t>{{FUNCTION_BREAKDOWN}}</a:t>
+            </a:r>
+          </a:p>
+        </p:txBody>
+      </p:sp>
+      <p:sp>
+        <p:nvSpPr>
           <p:cNvPr id="29" name="Rectangle 28"/>
           <p:cNvSpPr/>
           <p:nvPr/>
         </p:nvSpPr>
         <p:spPr>
           <a:xfrm>
-            <a:off x="5468112" y="2496312"/>
-            <a:ext cx="6537959" cy="45720"/>
+            <a:off x="5568696" y="2560320"/>
+            <a:ext cx="6345936" cy="4041647"/>
           </a:xfrm>
           <a:prstGeom prst="rect">
             <a:avLst/>
           </a:prstGeom>
           <a:solidFill>
-            <a:srgbClr val="2C6E66"/>
+            <a:srgbClr val="FFFFFF"/>
           </a:solidFill>
-          <a:ln>
-            <a:noFill/>
+          <a:ln w="9525">
+            <a:solidFill>
+              <a:srgbClr val="DEDEDE"/>
+            </a:solidFill>
           </a:ln>
+          <a:effectLst/>
         </p:spPr>
         <p:style>
           <a:lnRef idx="1">
@@ -6967,58 +7217,25 @@
       </p:sp>
       <p:sp>
         <p:nvSpPr>
-          <p:cNvPr id="30" name="TextBox 29"/>
-          <p:cNvSpPr txBox="1"/>
-          <p:nvPr/>
-        </p:nvSpPr>
-        <p:spPr>
-          <a:xfrm>
-            <a:off x="5605272" y="2633472"/>
-            <a:ext cx="6263640" cy="256032"/>
-          </a:xfrm>
-          <a:prstGeom prst="rect">
-            <a:avLst/>
-          </a:prstGeom>
-          <a:noFill/>
-        </p:spPr>
-        <p:txBody>
-          <a:bodyPr wrap="square" anchor="t">
-            <a:spAutoFit/>
-          </a:bodyPr>
-          <a:lstStyle/>
-          <a:p>
-            <a:pPr algn="l"/>
-            <a:r>
-              <a:rPr sz="1100" b="1" i="0">
-                <a:solidFill>
-                  <a:srgbClr val="2C6E66"/>
-                </a:solidFill>
-              </a:rPr>
-              <a:t>FUNCTION DISTRIBUTION</a:t>
-            </a:r>
-          </a:p>
-        </p:txBody>
-      </p:sp>
-      <p:sp>
-        <p:nvSpPr>
-          <p:cNvPr id="31" name="Rectangle 30"/>
+          <p:cNvPr id="30" name="Rectangle 29"/>
           <p:cNvSpPr/>
           <p:nvPr/>
         </p:nvSpPr>
         <p:spPr>
           <a:xfrm>
-            <a:off x="5605272" y="2926079"/>
-            <a:ext cx="6263640" cy="20116"/>
+            <a:off x="5568696" y="2560320"/>
+            <a:ext cx="6345936" cy="54864"/>
           </a:xfrm>
           <a:prstGeom prst="rect">
             <a:avLst/>
           </a:prstGeom>
           <a:solidFill>
-            <a:srgbClr val="7FB2A9"/>
+            <a:srgbClr val="3A8B82"/>
           </a:solidFill>
           <a:ln>
             <a:noFill/>
           </a:ln>
+          <a:effectLst/>
         </p:spPr>
         <p:style>
           <a:lnRef idx="1">
@@ -7044,14 +7261,14 @@
       </p:sp>
       <p:sp>
         <p:nvSpPr>
-          <p:cNvPr id="32" name="TextBox 31"/>
+          <p:cNvPr id="31" name="TextBox 30"/>
           <p:cNvSpPr txBox="1"/>
           <p:nvPr/>
         </p:nvSpPr>
         <p:spPr>
           <a:xfrm>
-            <a:off x="5605272" y="2980944"/>
-            <a:ext cx="6263640" cy="3694175"/>
+            <a:off x="5715000" y="2706624"/>
+            <a:ext cx="6053328" cy="256032"/>
           </a:xfrm>
           <a:prstGeom prst="rect">
             <a:avLst/>
@@ -7059,17 +7276,97 @@
           <a:noFill/>
         </p:spPr>
         <p:txBody>
-          <a:bodyPr wrap="square" anchor="t">
+          <a:bodyPr wrap="square" anchor="t" tIns="0" bIns="0">
             <a:spAutoFit/>
           </a:bodyPr>
           <a:lstStyle/>
           <a:p>
             <a:pPr algn="l"/>
             <a:r>
+              <a:rPr sz="1100" b="1" i="0">
+                <a:solidFill>
+                  <a:srgbClr val="3A8B82"/>
+                </a:solidFill>
+                <a:latin typeface="Calibri"/>
+              </a:rPr>
+              <a:t>FUNCTION DISTRIBUTION</a:t>
+            </a:r>
+          </a:p>
+        </p:txBody>
+      </p:sp>
+      <p:sp>
+        <p:nvSpPr>
+          <p:cNvPr id="32" name="Rectangle 31"/>
+          <p:cNvSpPr/>
+          <p:nvPr/>
+        </p:nvSpPr>
+        <p:spPr>
+          <a:xfrm>
+            <a:off x="5715000" y="2980944"/>
+            <a:ext cx="6053328" cy="20116"/>
+          </a:xfrm>
+          <a:prstGeom prst="rect">
+            <a:avLst/>
+          </a:prstGeom>
+          <a:solidFill>
+            <a:srgbClr val="3A8B82"/>
+          </a:solidFill>
+          <a:ln>
+            <a:noFill/>
+          </a:ln>
+          <a:effectLst/>
+        </p:spPr>
+        <p:style>
+          <a:lnRef idx="1">
+            <a:schemeClr val="accent1"/>
+          </a:lnRef>
+          <a:fillRef idx="3">
+            <a:schemeClr val="accent1"/>
+          </a:fillRef>
+          <a:effectRef idx="2">
+            <a:schemeClr val="accent1"/>
+          </a:effectRef>
+          <a:fontRef idx="minor">
+            <a:schemeClr val="lt1"/>
+          </a:fontRef>
+        </p:style>
+        <p:txBody>
+          <a:bodyPr rtlCol="0" anchor="ctr"/>
+          <a:lstStyle/>
+          <a:p>
+            <a:pPr algn="ctr"/>
+          </a:p>
+        </p:txBody>
+      </p:sp>
+      <p:sp>
+        <p:nvSpPr>
+          <p:cNvPr id="33" name="TextBox 32"/>
+          <p:cNvSpPr txBox="1"/>
+          <p:nvPr/>
+        </p:nvSpPr>
+        <p:spPr>
+          <a:xfrm>
+            <a:off x="5715000" y="3108960"/>
+            <a:ext cx="6053328" cy="3419855"/>
+          </a:xfrm>
+          <a:prstGeom prst="rect">
+            <a:avLst/>
+          </a:prstGeom>
+          <a:noFill/>
+        </p:spPr>
+        <p:txBody>
+          <a:bodyPr wrap="square" anchor="t" tIns="0" bIns="0">
+            <a:spAutoFit/>
+          </a:bodyPr>
+          <a:lstStyle/>
+          <a:p>
+            <a:pPr algn="l"/>
+            <a:r>
               <a:rPr sz="1000" b="0" i="0">
                 <a:solidFill>
-                  <a:srgbClr val="555555"/>
+                  <a:srgbClr val="6E6E69"/>
                 </a:solidFill>
+                <a:latin typeface="Calibri"/>
               </a:rPr>
               <a:t>{{CHART}}</a:t>
             </a:r>

</xml_diff>